<commit_message>
Doc: Them slide model seq2seq va transformer.
</commit_message>
<xml_diff>
--- a/docs/Nhom12_SlideBaoCaoCuoiKy.pptx
+++ b/docs/Nhom12_SlideBaoCaoCuoiKy.pptx
@@ -5,7 +5,7 @@
     <p:sldMasterId id="2147483648" r:id="rId1"/>
   </p:sldMasterIdLst>
   <p:notesMasterIdLst>
-    <p:notesMasterId r:id="rId20"/>
+    <p:notesMasterId r:id="rId22"/>
   </p:notesMasterIdLst>
   <p:sldIdLst>
     <p:sldId id="256" r:id="rId2"/>
@@ -23,21 +23,23 @@
     <p:sldId id="312" r:id="rId14"/>
     <p:sldId id="313" r:id="rId15"/>
     <p:sldId id="302" r:id="rId16"/>
-    <p:sldId id="303" r:id="rId17"/>
-    <p:sldId id="304" r:id="rId18"/>
-    <p:sldId id="297" r:id="rId19"/>
+    <p:sldId id="314" r:id="rId17"/>
+    <p:sldId id="315" r:id="rId18"/>
+    <p:sldId id="303" r:id="rId19"/>
+    <p:sldId id="304" r:id="rId20"/>
+    <p:sldId id="297" r:id="rId21"/>
   </p:sldIdLst>
   <p:sldSz cx="5753100" cy="3238500"/>
   <p:notesSz cx="6858000" cy="9144000"/>
   <p:embeddedFontLst>
     <p:embeddedFont>
       <p:font typeface="Cambria Math" panose="02040503050406030204" pitchFamily="18" charset="0"/>
-      <p:regular r:id="rId21"/>
+      <p:regular r:id="rId23"/>
     </p:embeddedFont>
     <p:embeddedFont>
       <p:font typeface="Tahoma" panose="020B0604030504040204" pitchFamily="34" charset="0"/>
-      <p:regular r:id="rId22"/>
-      <p:bold r:id="rId23"/>
+      <p:regular r:id="rId24"/>
+      <p:bold r:id="rId25"/>
     </p:embeddedFont>
   </p:embeddedFontLst>
   <p:defaultTextStyle>
@@ -930,6 +932,409 @@
         </p:txBody>
       </p:sp>
     </p:spTree>
+  </p:cSld>
+  <p:clrMapOvr>
+    <a:masterClrMapping/>
+  </p:clrMapOvr>
+</p:notes>
+</file>
+
+<file path=ppt/notesSlides/notesSlide3.xml><?xml version="1.0" encoding="utf-8"?>
+<p:notes xmlns:a="http://schemas.openxmlformats.org/drawingml/2006/main" xmlns:r="http://schemas.openxmlformats.org/officeDocument/2006/relationships" xmlns:p="http://schemas.openxmlformats.org/presentationml/2006/main">
+  <p:cSld>
+    <p:spTree>
+      <p:nvGrpSpPr>
+        <p:cNvPr id="1" name=""/>
+        <p:cNvGrpSpPr/>
+        <p:nvPr/>
+      </p:nvGrpSpPr>
+      <p:grpSpPr>
+        <a:xfrm>
+          <a:off x="0" y="0"/>
+          <a:ext cx="0" cy="0"/>
+          <a:chOff x="0" y="0"/>
+          <a:chExt cx="0" cy="0"/>
+        </a:xfrm>
+      </p:grpSpPr>
+      <p:sp>
+        <p:nvSpPr>
+          <p:cNvPr id="2" name="Slide Image Placeholder 1"/>
+          <p:cNvSpPr>
+            <a:spLocks noGrp="1" noRot="1" noChangeAspect="1"/>
+          </p:cNvSpPr>
+          <p:nvPr>
+            <p:ph type="sldImg"/>
+          </p:nvPr>
+        </p:nvSpPr>
+        <p:spPr>
+          <a:xfrm>
+            <a:off x="2292350" y="512763"/>
+            <a:ext cx="4559300" cy="2566987"/>
+          </a:xfrm>
+        </p:spPr>
+      </p:sp>
+      <p:sp>
+        <p:nvSpPr>
+          <p:cNvPr id="3" name="Notes Placeholder 2"/>
+          <p:cNvSpPr>
+            <a:spLocks noGrp="1"/>
+          </p:cNvSpPr>
+          <p:nvPr>
+            <p:ph type="body" idx="1"/>
+          </p:nvPr>
+        </p:nvSpPr>
+        <p:spPr/>
+        <p:txBody>
+          <a:bodyPr/>
+          <a:lstStyle/>
+          <a:p>
+            <a:pPr marL="171450" indent="-171450">
+              <a:buFont typeface="Arial" panose="020B0604020202020204" pitchFamily="34" charset="0"/>
+              <a:buChar char="•"/>
+            </a:pPr>
+            <a:r>
+              <a:rPr lang="vi-VN" dirty="0"/>
+              <a:t>Ở phần này, em giới thiệu mô hình Sequence-to-Sequence, hay còn gọi là Seq2Seq, một kiến trúc rất quan trọng trong xử lý ngôn ngữ tự nhiên, đặc biệt là trong bài toán dịch máy.</a:t>
+            </a:r>
+          </a:p>
+          <a:p>
+            <a:pPr marL="171450" indent="-171450">
+              <a:buFont typeface="Arial" panose="020B0604020202020204" pitchFamily="34" charset="0"/>
+              <a:buChar char="•"/>
+            </a:pPr>
+            <a:r>
+              <a:rPr lang="vi-VN" dirty="0"/>
+              <a:t>Ý tưởng chính của mô hình là chuyển đổi một chuỗi đầu vào sang một chuỗi đầu ra, ví dụ như dịch từ tiếng Anh sang tiếng Việt, trong đó độ dài hai chuỗi có thể khác nhau.</a:t>
+            </a:r>
+          </a:p>
+          <a:p>
+            <a:pPr marL="171450" indent="-171450">
+              <a:buFont typeface="Arial" panose="020B0604020202020204" pitchFamily="34" charset="0"/>
+              <a:buChar char="•"/>
+            </a:pPr>
+            <a:r>
+              <a:rPr lang="vi-VN" dirty="0"/>
+              <a:t>Mô hình Seq2Seq gồm hai thành phần chính là Encoder và Decoder.</a:t>
+            </a:r>
+          </a:p>
+          <a:p>
+            <a:pPr marL="171450" indent="-171450">
+              <a:buFont typeface="Arial" panose="020B0604020202020204" pitchFamily="34" charset="0"/>
+              <a:buChar char="•"/>
+            </a:pPr>
+            <a:r>
+              <a:rPr lang="vi-VN" dirty="0"/>
+              <a:t>Encoder có nhiệm vụ đọc toàn bộ câu đầu vào và mã hóa nó thành một vector gọi là context vector. Vector này được xem như một dạng biểu diễn cô đọng toàn bộ ý nghĩa của câu.</a:t>
+            </a:r>
+          </a:p>
+          <a:p>
+            <a:pPr marL="171450" indent="-171450">
+              <a:buFont typeface="Arial" panose="020B0604020202020204" pitchFamily="34" charset="0"/>
+              <a:buChar char="•"/>
+            </a:pPr>
+            <a:r>
+              <a:rPr lang="vi-VN" dirty="0"/>
+              <a:t>Sau đó, Decoder sẽ sử dụng vector này để sinh ra câu đầu ra từng từ một. Quá trình sinh diễn ra tuần tự, bắt đầu từ token </a:t>
+            </a:r>
+            <a:r>
+              <a:rPr lang="vi-VN" sz="1200" kern="1200" dirty="0">
+                <a:solidFill>
+                  <a:schemeClr val="tx1"/>
+                </a:solidFill>
+                <a:latin typeface="+mn-lt"/>
+                <a:ea typeface="+mn-ea"/>
+                <a:cs typeface="+mn-cs"/>
+              </a:rPr>
+              <a:t>&lt;sos&gt;</a:t>
+            </a:r>
+            <a:r>
+              <a:rPr lang="vi-VN" dirty="0"/>
+              <a:t> và kết thúc khi sinh ra </a:t>
+            </a:r>
+            <a:r>
+              <a:rPr lang="vi-VN" sz="1200" kern="1200" dirty="0">
+                <a:solidFill>
+                  <a:schemeClr val="tx1"/>
+                </a:solidFill>
+                <a:latin typeface="+mn-lt"/>
+                <a:ea typeface="+mn-ea"/>
+                <a:cs typeface="+mn-cs"/>
+              </a:rPr>
+              <a:t>&lt;eos&gt;</a:t>
+            </a:r>
+            <a:r>
+              <a:rPr lang="vi-VN" dirty="0"/>
+              <a:t>.</a:t>
+            </a:r>
+          </a:p>
+          <a:p>
+            <a:pPr marL="171450" indent="-171450">
+              <a:buFont typeface="Arial" panose="020B0604020202020204" pitchFamily="34" charset="0"/>
+              <a:buChar char="•"/>
+            </a:pPr>
+            <a:r>
+              <a:rPr lang="vi-VN" dirty="0"/>
+              <a:t>Trong quá trình này, mô hình hoạt động theo dạng autoregressive, tức là mỗi từ sinh ra sẽ phụ thuộc vào các từ đã sinh trước đó.</a:t>
+            </a:r>
+          </a:p>
+          <a:p>
+            <a:pPr marL="171450" indent="-171450">
+              <a:buFont typeface="Arial" panose="020B0604020202020204" pitchFamily="34" charset="0"/>
+              <a:buChar char="•"/>
+            </a:pPr>
+            <a:r>
+              <a:rPr lang="vi-VN" dirty="0"/>
+              <a:t>Tuy nhiên, điểm hạn chế lớn của Seq2Seq là việc nén toàn bộ thông tin của câu vào một vector duy nhất, dẫn đến mất thông tin khi câu quá dài, đồng thời mô hình phải xử lý tuần tự nên không thể song song hóa.</a:t>
+            </a:r>
+          </a:p>
+          <a:p>
+            <a:pPr marL="171450" indent="-171450">
+              <a:buFont typeface="Arial" panose="020B0604020202020204" pitchFamily="34" charset="0"/>
+              <a:buChar char="•"/>
+            </a:pPr>
+            <a:r>
+              <a:rPr lang="vi-VN" dirty="0"/>
+              <a:t>Chính vì những hạn chế này, các phương pháp cải tiến như Attention và sau này là Transformer đã được đề xuất để khắc phục</a:t>
+            </a:r>
+          </a:p>
+          <a:p>
+            <a:pPr marL="171450" indent="-171450">
+              <a:buFont typeface="Arial" panose="020B0604020202020204" pitchFamily="34" charset="0"/>
+              <a:buChar char="•"/>
+            </a:pPr>
+            <a:endParaRPr lang="en-US" dirty="0"/>
+          </a:p>
+        </p:txBody>
+      </p:sp>
+      <p:sp>
+        <p:nvSpPr>
+          <p:cNvPr id="4" name="Slide Number Placeholder 3"/>
+          <p:cNvSpPr>
+            <a:spLocks noGrp="1"/>
+          </p:cNvSpPr>
+          <p:nvPr>
+            <p:ph type="sldNum" sz="quarter" idx="5"/>
+          </p:nvPr>
+        </p:nvSpPr>
+        <p:spPr/>
+        <p:txBody>
+          <a:bodyPr/>
+          <a:lstStyle/>
+          <a:p>
+            <a:fld id="{871B2431-D351-4C6E-A3CF-9DFAC0E3E050}" type="slidenum">
+              <a:rPr lang="cs-CZ" smtClean="0"/>
+              <a:t>16</a:t>
+            </a:fld>
+            <a:endParaRPr lang="cs-CZ"/>
+          </a:p>
+        </p:txBody>
+      </p:sp>
+    </p:spTree>
+    <p:extLst>
+      <p:ext uri="{BB962C8B-B14F-4D97-AF65-F5344CB8AC3E}">
+        <p14:creationId xmlns:p14="http://schemas.microsoft.com/office/powerpoint/2010/main" val="2962039876"/>
+      </p:ext>
+    </p:extLst>
+  </p:cSld>
+  <p:clrMapOvr>
+    <a:masterClrMapping/>
+  </p:clrMapOvr>
+</p:notes>
+</file>
+
+<file path=ppt/notesSlides/notesSlide4.xml><?xml version="1.0" encoding="utf-8"?>
+<p:notes xmlns:a="http://schemas.openxmlformats.org/drawingml/2006/main" xmlns:r="http://schemas.openxmlformats.org/officeDocument/2006/relationships" xmlns:p="http://schemas.openxmlformats.org/presentationml/2006/main">
+  <p:cSld>
+    <p:spTree>
+      <p:nvGrpSpPr>
+        <p:cNvPr id="1" name="">
+          <a:extLst>
+            <a:ext uri="{FF2B5EF4-FFF2-40B4-BE49-F238E27FC236}">
+              <a16:creationId xmlns:a16="http://schemas.microsoft.com/office/drawing/2014/main" id="{4BF6DD60-EBD2-3F82-D1D3-ACC729FDEE4C}"/>
+            </a:ext>
+          </a:extLst>
+        </p:cNvPr>
+        <p:cNvGrpSpPr/>
+        <p:nvPr/>
+      </p:nvGrpSpPr>
+      <p:grpSpPr>
+        <a:xfrm>
+          <a:off x="0" y="0"/>
+          <a:ext cx="0" cy="0"/>
+          <a:chOff x="0" y="0"/>
+          <a:chExt cx="0" cy="0"/>
+        </a:xfrm>
+      </p:grpSpPr>
+      <p:sp>
+        <p:nvSpPr>
+          <p:cNvPr id="2" name="Slide Image Placeholder 1">
+            <a:extLst>
+              <a:ext uri="{FF2B5EF4-FFF2-40B4-BE49-F238E27FC236}">
+                <a16:creationId xmlns:a16="http://schemas.microsoft.com/office/drawing/2014/main" id="{E66F2444-70AE-E7B8-983D-7143EE904981}"/>
+              </a:ext>
+            </a:extLst>
+          </p:cNvPr>
+          <p:cNvSpPr>
+            <a:spLocks noGrp="1" noRot="1" noChangeAspect="1"/>
+          </p:cNvSpPr>
+          <p:nvPr>
+            <p:ph type="sldImg"/>
+          </p:nvPr>
+        </p:nvSpPr>
+        <p:spPr>
+          <a:xfrm>
+            <a:off x="2292350" y="512763"/>
+            <a:ext cx="4559300" cy="2566987"/>
+          </a:xfrm>
+        </p:spPr>
+      </p:sp>
+      <p:sp>
+        <p:nvSpPr>
+          <p:cNvPr id="3" name="Notes Placeholder 2">
+            <a:extLst>
+              <a:ext uri="{FF2B5EF4-FFF2-40B4-BE49-F238E27FC236}">
+                <a16:creationId xmlns:a16="http://schemas.microsoft.com/office/drawing/2014/main" id="{AE41DEE6-2FA2-A203-1665-1347FADBD16F}"/>
+              </a:ext>
+            </a:extLst>
+          </p:cNvPr>
+          <p:cNvSpPr>
+            <a:spLocks noGrp="1"/>
+          </p:cNvSpPr>
+          <p:nvPr>
+            <p:ph type="body" idx="1"/>
+          </p:nvPr>
+        </p:nvSpPr>
+        <p:spPr/>
+        <p:txBody>
+          <a:bodyPr/>
+          <a:lstStyle/>
+          <a:p>
+            <a:pPr marL="171450" indent="-171450">
+              <a:buFont typeface="Arial" panose="020B0604020202020204" pitchFamily="34" charset="0"/>
+              <a:buChar char="•"/>
+            </a:pPr>
+            <a:r>
+              <a:rPr lang="vi-VN" dirty="0"/>
+              <a:t>Ở phần này, em trình bày về mô hình Transformer, một kiến trúc hiện đại được đề xuất nhằm khắc phục hạn chế của các mô hình tuần tự như RNN hay Seq2Seq.</a:t>
+            </a:r>
+          </a:p>
+          <a:p>
+            <a:pPr marL="171450" indent="-171450">
+              <a:buFont typeface="Arial" panose="020B0604020202020204" pitchFamily="34" charset="0"/>
+              <a:buChar char="•"/>
+            </a:pPr>
+            <a:r>
+              <a:rPr lang="vi-VN" dirty="0"/>
+              <a:t>Khác với các mô hình trước đó, Transformer không sử dụng RNN mà hoàn toàn dựa trên cơ chế Attention. Điều này giúp mô hình có thể xử lý song song toàn bộ chuỗi đầu vào, từ đó tăng tốc độ huấn luyện và cải thiện khả năng học phụ thuộc dài hạn trong câu.</a:t>
+            </a:r>
+          </a:p>
+          <a:p>
+            <a:pPr marL="171450" indent="-171450">
+              <a:buFont typeface="Arial" panose="020B0604020202020204" pitchFamily="34" charset="0"/>
+              <a:buChar char="•"/>
+            </a:pPr>
+            <a:r>
+              <a:rPr lang="vi-VN" dirty="0"/>
+              <a:t>Kiến trúc Transformer gồm hai thành phần chính là Encoder và Decoder.</a:t>
+            </a:r>
+          </a:p>
+          <a:p>
+            <a:pPr marL="171450" indent="-171450">
+              <a:buFont typeface="Arial" panose="020B0604020202020204" pitchFamily="34" charset="0"/>
+              <a:buChar char="•"/>
+            </a:pPr>
+            <a:r>
+              <a:rPr lang="vi-VN" dirty="0"/>
+              <a:t>Encoder có nhiệm vụ chuyển câu đầu vào thành các biểu diễn ngữ nghĩa giàu thông tin thông qua cơ chế Self-Attention. Decoder sử dụng các biểu diễn này để sinh ra câu đầu ra.</a:t>
+            </a:r>
+          </a:p>
+          <a:p>
+            <a:pPr marL="171450" indent="-171450">
+              <a:buFont typeface="Arial" panose="020B0604020202020204" pitchFamily="34" charset="0"/>
+              <a:buChar char="•"/>
+            </a:pPr>
+            <a:r>
+              <a:rPr lang="vi-VN" dirty="0"/>
+              <a:t>Điểm cốt lõi của Transformer là cơ chế Self-Attention, cho phép mỗi từ trong câu có thể “nhìn” và tính mức độ liên quan với tất cả các từ còn lại, từ đó tạo ra biểu diễn ngữ cảnh tốt hơn so với việc chỉ xử lý tuần tự.</a:t>
+            </a:r>
+          </a:p>
+          <a:p>
+            <a:pPr marL="171450" indent="-171450">
+              <a:buFont typeface="Arial" panose="020B0604020202020204" pitchFamily="34" charset="0"/>
+              <a:buChar char="•"/>
+            </a:pPr>
+            <a:r>
+              <a:rPr lang="vi-VN" dirty="0"/>
+              <a:t>Ngoài ra, mỗi từ được biểu diễn thông qua ba vector là Query, Key và Value. Các vector này giúp mô hình xác định mức độ liên quan giữa các từ và tổng hợp thông tin phù hợp cho từng vị trí.</a:t>
+            </a:r>
+          </a:p>
+          <a:p>
+            <a:pPr marL="171450" indent="-171450">
+              <a:buFont typeface="Arial" panose="020B0604020202020204" pitchFamily="34" charset="0"/>
+              <a:buChar char="•"/>
+            </a:pPr>
+            <a:r>
+              <a:rPr lang="vi-VN" dirty="0"/>
+              <a:t>Transformer cũng sử dụng Multi-Head Attention, tức là nhiều cơ chế attention song song, giúp mô hình học được nhiều kiểu quan hệ khác nhau trong câu như ngữ pháp, ngữ nghĩa hoặc phụ thuộc xa.</a:t>
+            </a:r>
+          </a:p>
+          <a:p>
+            <a:pPr marL="171450" indent="-171450">
+              <a:buFont typeface="Arial" panose="020B0604020202020204" pitchFamily="34" charset="0"/>
+              <a:buChar char="•"/>
+            </a:pPr>
+            <a:r>
+              <a:rPr lang="vi-VN" dirty="0"/>
+              <a:t>Ở phía Decoder, ngoài Self-Attention còn có thêm Encoder–Decoder Attention để kết nối thông tin giữa câu nguồn và câu đích. Đồng thời, cơ chế masking được sử dụng để đảm bảo mô hình chỉ nhìn các từ đã sinh trước đó, tránh “nhìn trước” tương lai.</a:t>
+            </a:r>
+          </a:p>
+          <a:p>
+            <a:pPr marL="171450" indent="-171450">
+              <a:buFont typeface="Arial" panose="020B0604020202020204" pitchFamily="34" charset="0"/>
+              <a:buChar char="•"/>
+            </a:pPr>
+            <a:r>
+              <a:rPr lang="vi-VN" dirty="0"/>
+              <a:t>Nhờ những cải tiến này, Transformer đã trở thành nền tảng cho các mô hình hiện đại như BERT, GPT và các hệ thống dịch máy tiên tiến.</a:t>
+            </a:r>
+          </a:p>
+        </p:txBody>
+      </p:sp>
+      <p:sp>
+        <p:nvSpPr>
+          <p:cNvPr id="4" name="Slide Number Placeholder 3">
+            <a:extLst>
+              <a:ext uri="{FF2B5EF4-FFF2-40B4-BE49-F238E27FC236}">
+                <a16:creationId xmlns:a16="http://schemas.microsoft.com/office/drawing/2014/main" id="{994BFEB6-D76E-6992-F80E-9948773492F4}"/>
+              </a:ext>
+            </a:extLst>
+          </p:cNvPr>
+          <p:cNvSpPr>
+            <a:spLocks noGrp="1"/>
+          </p:cNvSpPr>
+          <p:nvPr>
+            <p:ph type="sldNum" sz="quarter" idx="5"/>
+          </p:nvPr>
+        </p:nvSpPr>
+        <p:spPr/>
+        <p:txBody>
+          <a:bodyPr/>
+          <a:lstStyle/>
+          <a:p>
+            <a:fld id="{871B2431-D351-4C6E-A3CF-9DFAC0E3E050}" type="slidenum">
+              <a:rPr lang="cs-CZ" smtClean="0"/>
+              <a:t>17</a:t>
+            </a:fld>
+            <a:endParaRPr lang="cs-CZ"/>
+          </a:p>
+        </p:txBody>
+      </p:sp>
+    </p:spTree>
+    <p:extLst>
+      <p:ext uri="{BB962C8B-B14F-4D97-AF65-F5344CB8AC3E}">
+        <p14:creationId xmlns:p14="http://schemas.microsoft.com/office/powerpoint/2010/main" val="4170018140"/>
+      </p:ext>
+    </p:extLst>
   </p:cSld>
   <p:clrMapOvr>
     <a:masterClrMapping/>
@@ -5573,8 +5978,8 @@
           </a:p>
         </p:txBody>
       </p:sp>
-      <mc:AlternateContent xmlns:mc="http://schemas.openxmlformats.org/markup-compatibility/2006">
-        <mc:Choice xmlns:a14="http://schemas.microsoft.com/office/drawing/2010/main" Requires="a14">
+      <mc:AlternateContent xmlns:mc="http://schemas.openxmlformats.org/markup-compatibility/2006" xmlns:a14="http://schemas.microsoft.com/office/drawing/2010/main">
+        <mc:Choice Requires="a14">
           <p:sp>
             <p:nvSpPr>
               <p:cNvPr id="9" name="TextBox 8">
@@ -6028,7 +6433,7 @@
             </p:txBody>
           </p:sp>
         </mc:Choice>
-        <mc:Fallback>
+        <mc:Fallback xmlns="">
           <p:sp>
             <p:nvSpPr>
               <p:cNvPr id="9" name="TextBox 8">
@@ -6732,8 +7137,8 @@
           </a:p>
         </p:txBody>
       </p:sp>
-      <mc:AlternateContent xmlns:mc="http://schemas.openxmlformats.org/markup-compatibility/2006">
-        <mc:Choice xmlns:a14="http://schemas.microsoft.com/office/drawing/2010/main" Requires="a14">
+      <mc:AlternateContent xmlns:mc="http://schemas.openxmlformats.org/markup-compatibility/2006" xmlns:a14="http://schemas.microsoft.com/office/drawing/2010/main">
+        <mc:Choice Requires="a14">
           <p:sp>
             <p:nvSpPr>
               <p:cNvPr id="9" name="TextBox 8">
@@ -6847,30 +7252,42 @@
                         <m:t>𝐵</m:t>
                       </m:r>
                       <m:r>
-                        <a:rPr lang="en-US" sz="900" i="1"/>
+                        <a:rPr lang="en-US" sz="900" i="1">
+                          <a:latin typeface="Cambria Math" panose="02040503050406030204" pitchFamily="18" charset="0"/>
+                        </a:rPr>
                         <m:t>𝐿𝐸𝑈</m:t>
                       </m:r>
                       <m:r>
-                        <a:rPr lang="en-US" sz="900" i="1"/>
+                        <a:rPr lang="en-US" sz="900" i="1">
+                          <a:latin typeface="Cambria Math" panose="02040503050406030204" pitchFamily="18" charset="0"/>
+                        </a:rPr>
                         <m:t>=</m:t>
                       </m:r>
                       <m:r>
-                        <a:rPr lang="en-US" sz="900" i="1"/>
+                        <a:rPr lang="en-US" sz="900" i="1">
+                          <a:latin typeface="Cambria Math" panose="02040503050406030204" pitchFamily="18" charset="0"/>
+                        </a:rPr>
                         <m:t>𝐵𝑃</m:t>
                       </m:r>
                       <m:r>
-                        <a:rPr lang="en-US" sz="900" i="1"/>
+                        <a:rPr lang="en-US" sz="900" i="1">
+                          <a:latin typeface="Cambria Math" panose="02040503050406030204" pitchFamily="18" charset="0"/>
+                        </a:rPr>
                         <m:t>∙</m:t>
                       </m:r>
                       <m:r>
                         <m:rPr>
                           <m:sty m:val="p"/>
                         </m:rPr>
-                        <a:rPr lang="en-US" sz="900"/>
+                        <a:rPr lang="en-US" sz="900">
+                          <a:latin typeface="Cambria Math" panose="02040503050406030204" pitchFamily="18" charset="0"/>
+                        </a:rPr>
                         <m:t>exp</m:t>
                       </m:r>
                       <m:r>
-                        <a:rPr lang="en-US" sz="900" i="1"/>
+                        <a:rPr lang="en-US" sz="900" i="1">
+                          <a:latin typeface="Cambria Math" panose="02040503050406030204" pitchFamily="18" charset="0"/>
+                        </a:rPr>
                         <m:t>(</m:t>
                       </m:r>
                       <m:nary>
@@ -6878,22 +7295,30 @@
                           <m:chr m:val="∑"/>
                           <m:limLoc m:val="undOvr"/>
                           <m:ctrlPr>
-                            <a:rPr lang="en-US" sz="900" i="1"/>
+                            <a:rPr lang="en-US" sz="900" i="1">
+                              <a:latin typeface="Cambria Math" panose="02040503050406030204" pitchFamily="18" charset="0"/>
+                            </a:rPr>
                           </m:ctrlPr>
                         </m:naryPr>
                         <m:sub>
                           <m:r>
-                            <a:rPr lang="en-US" sz="900" i="1"/>
+                            <a:rPr lang="en-US" sz="900" i="1">
+                              <a:latin typeface="Cambria Math" panose="02040503050406030204" pitchFamily="18" charset="0"/>
+                            </a:rPr>
                             <m:t>𝑛</m:t>
                           </m:r>
                           <m:r>
-                            <a:rPr lang="en-US" sz="900" i="1"/>
+                            <a:rPr lang="en-US" sz="900" i="1">
+                              <a:latin typeface="Cambria Math" panose="02040503050406030204" pitchFamily="18" charset="0"/>
+                            </a:rPr>
                             <m:t>=1</m:t>
                           </m:r>
                         </m:sub>
                         <m:sup>
                           <m:r>
-                            <a:rPr lang="en-US" sz="900" i="1"/>
+                            <a:rPr lang="en-US" sz="900" i="1">
+                              <a:latin typeface="Cambria Math" panose="02040503050406030204" pitchFamily="18" charset="0"/>
+                            </a:rPr>
                             <m:t>𝑁</m:t>
                           </m:r>
                         </m:sup>
@@ -6901,18 +7326,24 @@
                           <m:sSub>
                             <m:sSubPr>
                               <m:ctrlPr>
-                                <a:rPr lang="en-US" sz="900" i="1"/>
+                                <a:rPr lang="en-US" sz="900" i="1">
+                                  <a:latin typeface="Cambria Math" panose="02040503050406030204" pitchFamily="18" charset="0"/>
+                                </a:rPr>
                               </m:ctrlPr>
                             </m:sSubPr>
                             <m:e>
                               <m:r>
-                                <a:rPr lang="en-US" sz="900" i="1"/>
+                                <a:rPr lang="en-US" sz="900" i="1">
+                                  <a:latin typeface="Cambria Math" panose="02040503050406030204" pitchFamily="18" charset="0"/>
+                                </a:rPr>
                                 <m:t>𝑤</m:t>
                               </m:r>
                             </m:e>
                             <m:sub>
                               <m:r>
-                                <a:rPr lang="en-US" sz="900" i="1"/>
+                                <a:rPr lang="en-US" sz="900" i="1">
+                                  <a:latin typeface="Cambria Math" panose="02040503050406030204" pitchFamily="18" charset="0"/>
+                                </a:rPr>
                                 <m:t>𝑛</m:t>
                               </m:r>
                             </m:sub>
@@ -6920,7 +7351,9 @@
                           <m:func>
                             <m:funcPr>
                               <m:ctrlPr>
-                                <a:rPr lang="en-US" sz="900" i="1"/>
+                                <a:rPr lang="en-US" sz="900" i="1">
+                                  <a:latin typeface="Cambria Math" panose="02040503050406030204" pitchFamily="18" charset="0"/>
+                                </a:rPr>
                               </m:ctrlPr>
                             </m:funcPr>
                             <m:fName>
@@ -6928,7 +7361,9 @@
                                 <m:rPr>
                                   <m:sty m:val="p"/>
                                 </m:rPr>
-                                <a:rPr lang="en-US" sz="900"/>
+                                <a:rPr lang="en-US" sz="900">
+                                  <a:latin typeface="Cambria Math" panose="02040503050406030204" pitchFamily="18" charset="0"/>
+                                </a:rPr>
                                 <m:t>log</m:t>
                               </m:r>
                             </m:fName>
@@ -6936,18 +7371,24 @@
                               <m:sSub>
                                 <m:sSubPr>
                                   <m:ctrlPr>
-                                    <a:rPr lang="en-US" sz="900" i="1"/>
+                                    <a:rPr lang="en-US" sz="900" i="1">
+                                      <a:latin typeface="Cambria Math" panose="02040503050406030204" pitchFamily="18" charset="0"/>
+                                    </a:rPr>
                                   </m:ctrlPr>
                                 </m:sSubPr>
                                 <m:e>
                                   <m:r>
-                                    <a:rPr lang="en-US" sz="900" i="1"/>
+                                    <a:rPr lang="en-US" sz="900" i="1">
+                                      <a:latin typeface="Cambria Math" panose="02040503050406030204" pitchFamily="18" charset="0"/>
+                                    </a:rPr>
                                     <m:t>𝑝</m:t>
                                   </m:r>
                                 </m:e>
                                 <m:sub>
                                   <m:r>
-                                    <a:rPr lang="en-US" sz="900" i="1"/>
+                                    <a:rPr lang="en-US" sz="900" i="1">
+                                      <a:latin typeface="Cambria Math" panose="02040503050406030204" pitchFamily="18" charset="0"/>
+                                    </a:rPr>
                                     <m:t>𝑛</m:t>
                                   </m:r>
                                 </m:sub>
@@ -6957,7 +7398,9 @@
                         </m:e>
                       </m:nary>
                       <m:r>
-                        <a:rPr lang="en-US" sz="900" i="1"/>
+                        <a:rPr lang="en-US" sz="900" i="1">
+                          <a:latin typeface="Cambria Math" panose="02040503050406030204" pitchFamily="18" charset="0"/>
+                        </a:rPr>
                         <m:t>)</m:t>
                       </m:r>
                     </m:oMath>
@@ -7093,7 +7536,7 @@
             </p:txBody>
           </p:sp>
         </mc:Choice>
-        <mc:Fallback>
+        <mc:Fallback xmlns="">
           <p:sp>
             <p:nvSpPr>
               <p:cNvPr id="9" name="TextBox 8">
@@ -7468,7 +7911,7 @@
                 <a:cs typeface="Tahoma" panose="020B0604030504040204" pitchFamily="34" charset="0"/>
                 <a:sym typeface="Canva Sans"/>
               </a:rPr>
-              <a:t>10</a:t>
+              <a:t>14</a:t>
             </a:r>
             <a:endParaRPr lang="en-US" sz="800" dirty="0">
               <a:latin typeface="Tahoma" panose="020B0604030504040204" pitchFamily="34" charset="0"/>
@@ -7492,6 +7935,1246 @@
 </file>
 
 <file path=ppt/slides/slide16.xml><?xml version="1.0" encoding="utf-8"?>
+<p:sld xmlns:a="http://schemas.openxmlformats.org/drawingml/2006/main" xmlns:r="http://schemas.openxmlformats.org/officeDocument/2006/relationships" xmlns:p="http://schemas.openxmlformats.org/presentationml/2006/main">
+  <p:cSld>
+    <p:spTree>
+      <p:nvGrpSpPr>
+        <p:cNvPr id="1" name="">
+          <a:extLst>
+            <a:ext uri="{FF2B5EF4-FFF2-40B4-BE49-F238E27FC236}">
+              <a16:creationId xmlns:a16="http://schemas.microsoft.com/office/drawing/2014/main" id="{D0A7287E-DED4-7C48-DE93-69DA3FA67272}"/>
+            </a:ext>
+          </a:extLst>
+        </p:cNvPr>
+        <p:cNvGrpSpPr/>
+        <p:nvPr/>
+      </p:nvGrpSpPr>
+      <p:grpSpPr>
+        <a:xfrm>
+          <a:off x="0" y="0"/>
+          <a:ext cx="0" cy="0"/>
+          <a:chOff x="0" y="0"/>
+          <a:chExt cx="0" cy="0"/>
+        </a:xfrm>
+      </p:grpSpPr>
+      <p:sp>
+        <p:nvSpPr>
+          <p:cNvPr id="2" name="TextBox 2">
+            <a:extLst>
+              <a:ext uri="{FF2B5EF4-FFF2-40B4-BE49-F238E27FC236}">
+                <a16:creationId xmlns:a16="http://schemas.microsoft.com/office/drawing/2014/main" id="{9EA1CA48-D3E9-215E-48E1-D3C04EBBEB2C}"/>
+              </a:ext>
+            </a:extLst>
+          </p:cNvPr>
+          <p:cNvSpPr txBox="1"/>
+          <p:nvPr/>
+        </p:nvSpPr>
+        <p:spPr>
+          <a:xfrm>
+            <a:off x="277092" y="277825"/>
+            <a:ext cx="2675658" cy="241476"/>
+          </a:xfrm>
+          <a:prstGeom prst="rect">
+            <a:avLst/>
+          </a:prstGeom>
+        </p:spPr>
+        <p:txBody>
+          <a:bodyPr wrap="square" lIns="0" tIns="0" rIns="0" bIns="0" rtlCol="0" anchor="t">
+            <a:spAutoFit/>
+          </a:bodyPr>
+          <a:lstStyle/>
+          <a:p>
+            <a:pPr algn="l">
+              <a:lnSpc>
+                <a:spcPts val="2100"/>
+              </a:lnSpc>
+            </a:pPr>
+            <a:r>
+              <a:rPr lang="en-US" sz="1500" b="1" spc="-4" dirty="0">
+                <a:solidFill>
+                  <a:srgbClr val="2B4D7B"/>
+                </a:solidFill>
+                <a:latin typeface="Tahoma" panose="020B0604030504040204" pitchFamily="34" charset="0"/>
+                <a:ea typeface="Tahoma" panose="020B0604030504040204" pitchFamily="34" charset="0"/>
+                <a:cs typeface="Tahoma" panose="020B0604030504040204" pitchFamily="34" charset="0"/>
+                <a:sym typeface="Canva Sans Bold"/>
+              </a:rPr>
+              <a:t>4. Phương </a:t>
+            </a:r>
+            <a:r>
+              <a:rPr lang="en-US" sz="1500" b="1" spc="-4" dirty="0" err="1">
+                <a:solidFill>
+                  <a:srgbClr val="2B4D7B"/>
+                </a:solidFill>
+                <a:latin typeface="Tahoma" panose="020B0604030504040204" pitchFamily="34" charset="0"/>
+                <a:ea typeface="Tahoma" panose="020B0604030504040204" pitchFamily="34" charset="0"/>
+                <a:cs typeface="Tahoma" panose="020B0604030504040204" pitchFamily="34" charset="0"/>
+                <a:sym typeface="Canva Sans Bold"/>
+              </a:rPr>
+              <a:t>pháp</a:t>
+            </a:r>
+            <a:endParaRPr lang="en-US" sz="1500" b="1" spc="-4" dirty="0">
+              <a:solidFill>
+                <a:srgbClr val="2B4D7B"/>
+              </a:solidFill>
+              <a:latin typeface="Tahoma" panose="020B0604030504040204" pitchFamily="34" charset="0"/>
+              <a:ea typeface="Tahoma" panose="020B0604030504040204" pitchFamily="34" charset="0"/>
+              <a:cs typeface="Tahoma" panose="020B0604030504040204" pitchFamily="34" charset="0"/>
+              <a:sym typeface="Canva Sans Bold"/>
+            </a:endParaRPr>
+          </a:p>
+        </p:txBody>
+      </p:sp>
+      <p:sp>
+        <p:nvSpPr>
+          <p:cNvPr id="10" name="TextBox 9">
+            <a:extLst>
+              <a:ext uri="{FF2B5EF4-FFF2-40B4-BE49-F238E27FC236}">
+                <a16:creationId xmlns:a16="http://schemas.microsoft.com/office/drawing/2014/main" id="{429209CC-65AD-7F37-B55E-3C4E039919AB}"/>
+              </a:ext>
+            </a:extLst>
+          </p:cNvPr>
+          <p:cNvSpPr txBox="1"/>
+          <p:nvPr/>
+        </p:nvSpPr>
+        <p:spPr>
+          <a:xfrm>
+            <a:off x="5314950" y="2914650"/>
+            <a:ext cx="295275" cy="215444"/>
+          </a:xfrm>
+          <a:prstGeom prst="rect">
+            <a:avLst/>
+          </a:prstGeom>
+          <a:noFill/>
+        </p:spPr>
+        <p:txBody>
+          <a:bodyPr wrap="square">
+            <a:spAutoFit/>
+          </a:bodyPr>
+          <a:lstStyle/>
+          <a:p>
+            <a:pPr algn="r"/>
+            <a:r>
+              <a:rPr lang="en-US" sz="800" dirty="0">
+                <a:solidFill>
+                  <a:srgbClr val="1C1C1A"/>
+                </a:solidFill>
+                <a:latin typeface="Tahoma" panose="020B0604030504040204" pitchFamily="34" charset="0"/>
+                <a:ea typeface="Tahoma" panose="020B0604030504040204" pitchFamily="34" charset="0"/>
+                <a:cs typeface="Tahoma" panose="020B0604030504040204" pitchFamily="34" charset="0"/>
+                <a:sym typeface="Canva Sans"/>
+              </a:rPr>
+              <a:t>15</a:t>
+            </a:r>
+            <a:endParaRPr lang="en-US" sz="800" dirty="0">
+              <a:latin typeface="Tahoma" panose="020B0604030504040204" pitchFamily="34" charset="0"/>
+              <a:ea typeface="Tahoma" panose="020B0604030504040204" pitchFamily="34" charset="0"/>
+              <a:cs typeface="Tahoma" panose="020B0604030504040204" pitchFamily="34" charset="0"/>
+            </a:endParaRPr>
+          </a:p>
+        </p:txBody>
+      </p:sp>
+      <p:sp>
+        <p:nvSpPr>
+          <p:cNvPr id="9" name="TextBox 8">
+            <a:extLst>
+              <a:ext uri="{FF2B5EF4-FFF2-40B4-BE49-F238E27FC236}">
+                <a16:creationId xmlns:a16="http://schemas.microsoft.com/office/drawing/2014/main" id="{48612569-DF7E-D17A-3F35-BF17D9640968}"/>
+              </a:ext>
+            </a:extLst>
+          </p:cNvPr>
+          <p:cNvSpPr txBox="1"/>
+          <p:nvPr/>
+        </p:nvSpPr>
+        <p:spPr>
+          <a:xfrm>
+            <a:off x="277092" y="519301"/>
+            <a:ext cx="2675658" cy="251094"/>
+          </a:xfrm>
+          <a:prstGeom prst="rect">
+            <a:avLst/>
+          </a:prstGeom>
+          <a:noFill/>
+        </p:spPr>
+        <p:txBody>
+          <a:bodyPr wrap="square" rtlCol="0">
+            <a:spAutoFit/>
+          </a:bodyPr>
+          <a:lstStyle/>
+          <a:p>
+            <a:pPr algn="just">
+              <a:lnSpc>
+                <a:spcPct val="130000"/>
+              </a:lnSpc>
+            </a:pPr>
+            <a:r>
+              <a:rPr lang="en-US" sz="900" u="sng" dirty="0">
+                <a:solidFill>
+                  <a:srgbClr val="00B050"/>
+                </a:solidFill>
+                <a:latin typeface="Tahoma" panose="020B0604030504040204" pitchFamily="34" charset="0"/>
+                <a:ea typeface="Tahoma" panose="020B0604030504040204" pitchFamily="34" charset="0"/>
+                <a:cs typeface="Tahoma" panose="020B0604030504040204" pitchFamily="34" charset="0"/>
+              </a:rPr>
+              <a:t>4.1. </a:t>
+            </a:r>
+            <a:r>
+              <a:rPr lang="en-US" sz="900" u="sng" dirty="0" err="1">
+                <a:solidFill>
+                  <a:srgbClr val="00B050"/>
+                </a:solidFill>
+                <a:latin typeface="Tahoma" panose="020B0604030504040204" pitchFamily="34" charset="0"/>
+                <a:ea typeface="Tahoma" panose="020B0604030504040204" pitchFamily="34" charset="0"/>
+                <a:cs typeface="Tahoma" panose="020B0604030504040204" pitchFamily="34" charset="0"/>
+              </a:rPr>
+              <a:t>Mô</a:t>
+            </a:r>
+            <a:r>
+              <a:rPr lang="en-US" sz="900" u="sng" dirty="0">
+                <a:solidFill>
+                  <a:srgbClr val="00B050"/>
+                </a:solidFill>
+                <a:latin typeface="Tahoma" panose="020B0604030504040204" pitchFamily="34" charset="0"/>
+                <a:ea typeface="Tahoma" panose="020B0604030504040204" pitchFamily="34" charset="0"/>
+                <a:cs typeface="Tahoma" panose="020B0604030504040204" pitchFamily="34" charset="0"/>
+              </a:rPr>
+              <a:t> </a:t>
+            </a:r>
+            <a:r>
+              <a:rPr lang="en-US" sz="900" u="sng" dirty="0" err="1">
+                <a:solidFill>
+                  <a:srgbClr val="00B050"/>
+                </a:solidFill>
+                <a:latin typeface="Tahoma" panose="020B0604030504040204" pitchFamily="34" charset="0"/>
+                <a:ea typeface="Tahoma" panose="020B0604030504040204" pitchFamily="34" charset="0"/>
+                <a:cs typeface="Tahoma" panose="020B0604030504040204" pitchFamily="34" charset="0"/>
+              </a:rPr>
+              <a:t>hình</a:t>
+            </a:r>
+            <a:r>
+              <a:rPr lang="en-US" sz="900" u="sng" dirty="0">
+                <a:solidFill>
+                  <a:srgbClr val="00B050"/>
+                </a:solidFill>
+                <a:latin typeface="Tahoma" panose="020B0604030504040204" pitchFamily="34" charset="0"/>
+                <a:ea typeface="Tahoma" panose="020B0604030504040204" pitchFamily="34" charset="0"/>
+                <a:cs typeface="Tahoma" panose="020B0604030504040204" pitchFamily="34" charset="0"/>
+              </a:rPr>
+              <a:t> Sequence to Sequence</a:t>
+            </a:r>
+            <a:endParaRPr lang="vi-VN" sz="900" u="sng" dirty="0">
+              <a:solidFill>
+                <a:srgbClr val="00B050"/>
+              </a:solidFill>
+              <a:latin typeface="Tahoma" panose="020B0604030504040204" pitchFamily="34" charset="0"/>
+              <a:ea typeface="Tahoma" panose="020B0604030504040204" pitchFamily="34" charset="0"/>
+              <a:cs typeface="Tahoma" panose="020B0604030504040204" pitchFamily="34" charset="0"/>
+            </a:endParaRPr>
+          </a:p>
+        </p:txBody>
+      </p:sp>
+      <p:sp>
+        <p:nvSpPr>
+          <p:cNvPr id="3" name="TextBox 2">
+            <a:extLst>
+              <a:ext uri="{FF2B5EF4-FFF2-40B4-BE49-F238E27FC236}">
+                <a16:creationId xmlns:a16="http://schemas.microsoft.com/office/drawing/2014/main" id="{4BEC7CDA-4FF9-AD9C-25CD-CA344FD59D52}"/>
+              </a:ext>
+            </a:extLst>
+          </p:cNvPr>
+          <p:cNvSpPr txBox="1"/>
+          <p:nvPr/>
+        </p:nvSpPr>
+        <p:spPr>
+          <a:xfrm>
+            <a:off x="277092" y="760777"/>
+            <a:ext cx="2675658" cy="1673792"/>
+          </a:xfrm>
+          <a:prstGeom prst="rect">
+            <a:avLst/>
+          </a:prstGeom>
+          <a:noFill/>
+        </p:spPr>
+        <p:txBody>
+          <a:bodyPr wrap="square" rtlCol="0">
+            <a:spAutoFit/>
+          </a:bodyPr>
+          <a:lstStyle/>
+          <a:p>
+            <a:pPr algn="just">
+              <a:lnSpc>
+                <a:spcPct val="130000"/>
+              </a:lnSpc>
+            </a:pPr>
+            <a:r>
+              <a:rPr lang="vi-VN" sz="800" dirty="0">
+                <a:latin typeface="Tahoma" panose="020B0604030504040204" pitchFamily="34" charset="0"/>
+                <a:ea typeface="Tahoma" panose="020B0604030504040204" pitchFamily="34" charset="0"/>
+                <a:cs typeface="Tahoma" panose="020B0604030504040204" pitchFamily="34" charset="0"/>
+              </a:rPr>
+              <a:t>Mô hình Seq2Seq (Sequence-to-Sequence) được thiết kế để chuyển đổi một chuỗi dữ liệu đầu vào thành một chuỗi dữ liệu đầu ra khác.</a:t>
+            </a:r>
+            <a:endParaRPr lang="en-US" sz="800" dirty="0">
+              <a:latin typeface="Tahoma" panose="020B0604030504040204" pitchFamily="34" charset="0"/>
+              <a:ea typeface="Tahoma" panose="020B0604030504040204" pitchFamily="34" charset="0"/>
+              <a:cs typeface="Tahoma" panose="020B0604030504040204" pitchFamily="34" charset="0"/>
+            </a:endParaRPr>
+          </a:p>
+          <a:p>
+            <a:pPr algn="just">
+              <a:lnSpc>
+                <a:spcPct val="130000"/>
+              </a:lnSpc>
+            </a:pPr>
+            <a:endParaRPr lang="en-US" sz="800" dirty="0">
+              <a:latin typeface="Tahoma" panose="020B0604030504040204" pitchFamily="34" charset="0"/>
+              <a:ea typeface="Tahoma" panose="020B0604030504040204" pitchFamily="34" charset="0"/>
+              <a:cs typeface="Tahoma" panose="020B0604030504040204" pitchFamily="34" charset="0"/>
+            </a:endParaRPr>
+          </a:p>
+          <a:p>
+            <a:pPr algn="just">
+              <a:lnSpc>
+                <a:spcPct val="130000"/>
+              </a:lnSpc>
+            </a:pPr>
+            <a:r>
+              <a:rPr lang="vi-VN" sz="800" dirty="0">
+                <a:latin typeface="Tahoma" panose="020B0604030504040204" pitchFamily="34" charset="0"/>
+                <a:ea typeface="Tahoma" panose="020B0604030504040204" pitchFamily="34" charset="0"/>
+                <a:cs typeface="Tahoma" panose="020B0604030504040204" pitchFamily="34" charset="0"/>
+              </a:rPr>
+              <a:t>Các mô hình Seq2Seq được xây dựng theo kiến trúc Encoder–Decoder</a:t>
+            </a:r>
+            <a:r>
+              <a:rPr lang="en-US" sz="800" dirty="0">
+                <a:latin typeface="Tahoma" panose="020B0604030504040204" pitchFamily="34" charset="0"/>
+                <a:ea typeface="Tahoma" panose="020B0604030504040204" pitchFamily="34" charset="0"/>
+                <a:cs typeface="Tahoma" panose="020B0604030504040204" pitchFamily="34" charset="0"/>
+              </a:rPr>
+              <a:t>:</a:t>
+            </a:r>
+          </a:p>
+          <a:p>
+            <a:pPr marL="285750" indent="-171450" algn="just">
+              <a:lnSpc>
+                <a:spcPct val="130000"/>
+              </a:lnSpc>
+              <a:buFont typeface="Arial" panose="020B0604020202020204" pitchFamily="34" charset="0"/>
+              <a:buChar char="•"/>
+            </a:pPr>
+            <a:r>
+              <a:rPr lang="vi-VN" sz="800" dirty="0">
+                <a:latin typeface="Tahoma" panose="020B0604030504040204" pitchFamily="34" charset="0"/>
+                <a:ea typeface="Tahoma" panose="020B0604030504040204" pitchFamily="34" charset="0"/>
+                <a:cs typeface="Tahoma" panose="020B0604030504040204" pitchFamily="34" charset="0"/>
+              </a:rPr>
+              <a:t>Encoder: mã hóa chuỗi đầu vào thành một vector biểu diễn liên tục gọi là context vector.</a:t>
+            </a:r>
+          </a:p>
+          <a:p>
+            <a:pPr marL="285750" indent="-171450" algn="just">
+              <a:lnSpc>
+                <a:spcPct val="130000"/>
+              </a:lnSpc>
+              <a:buFont typeface="Arial" panose="020B0604020202020204" pitchFamily="34" charset="0"/>
+              <a:buChar char="•"/>
+            </a:pPr>
+            <a:r>
+              <a:rPr lang="vi-VN" sz="800" dirty="0">
+                <a:latin typeface="Tahoma" panose="020B0604030504040204" pitchFamily="34" charset="0"/>
+                <a:ea typeface="Tahoma" panose="020B0604030504040204" pitchFamily="34" charset="0"/>
+                <a:cs typeface="Tahoma" panose="020B0604030504040204" pitchFamily="34" charset="0"/>
+              </a:rPr>
+              <a:t>Decoder: sử dụng context vector để sinh ra chuỗi đầu ra theo từng bước thời gian.</a:t>
+            </a:r>
+          </a:p>
+        </p:txBody>
+      </p:sp>
+      <p:pic>
+        <p:nvPicPr>
+          <p:cNvPr id="5" name="Picture 4">
+            <a:extLst>
+              <a:ext uri="{FF2B5EF4-FFF2-40B4-BE49-F238E27FC236}">
+                <a16:creationId xmlns:a16="http://schemas.microsoft.com/office/drawing/2014/main" id="{F99FAABA-1688-F84C-98EA-BE1E73F1F35D}"/>
+              </a:ext>
+            </a:extLst>
+          </p:cNvPr>
+          <p:cNvPicPr>
+            <a:picLocks noChangeAspect="1"/>
+          </p:cNvPicPr>
+          <p:nvPr/>
+        </p:nvPicPr>
+        <p:blipFill>
+          <a:blip r:embed="rId3"/>
+          <a:stretch>
+            <a:fillRect/>
+          </a:stretch>
+        </p:blipFill>
+        <p:spPr>
+          <a:xfrm>
+            <a:off x="2952750" y="711880"/>
+            <a:ext cx="2581610" cy="1814740"/>
+          </a:xfrm>
+          <a:prstGeom prst="rect">
+            <a:avLst/>
+          </a:prstGeom>
+        </p:spPr>
+      </p:pic>
+    </p:spTree>
+    <p:extLst>
+      <p:ext uri="{BB962C8B-B14F-4D97-AF65-F5344CB8AC3E}">
+        <p14:creationId xmlns:p14="http://schemas.microsoft.com/office/powerpoint/2010/main" val="3607679162"/>
+      </p:ext>
+    </p:extLst>
+  </p:cSld>
+  <p:clrMapOvr>
+    <a:masterClrMapping/>
+  </p:clrMapOvr>
+</p:sld>
+</file>
+
+<file path=ppt/slides/slide17.xml><?xml version="1.0" encoding="utf-8"?>
+<p:sld xmlns:a="http://schemas.openxmlformats.org/drawingml/2006/main" xmlns:r="http://schemas.openxmlformats.org/officeDocument/2006/relationships" xmlns:p="http://schemas.openxmlformats.org/presentationml/2006/main">
+  <p:cSld>
+    <p:spTree>
+      <p:nvGrpSpPr>
+        <p:cNvPr id="1" name="">
+          <a:extLst>
+            <a:ext uri="{FF2B5EF4-FFF2-40B4-BE49-F238E27FC236}">
+              <a16:creationId xmlns:a16="http://schemas.microsoft.com/office/drawing/2014/main" id="{33A8699D-6D8B-757A-C92A-F603D919962D}"/>
+            </a:ext>
+          </a:extLst>
+        </p:cNvPr>
+        <p:cNvGrpSpPr/>
+        <p:nvPr/>
+      </p:nvGrpSpPr>
+      <p:grpSpPr>
+        <a:xfrm>
+          <a:off x="0" y="0"/>
+          <a:ext cx="0" cy="0"/>
+          <a:chOff x="0" y="0"/>
+          <a:chExt cx="0" cy="0"/>
+        </a:xfrm>
+      </p:grpSpPr>
+      <p:pic>
+        <p:nvPicPr>
+          <p:cNvPr id="7" name="Picture 6">
+            <a:extLst>
+              <a:ext uri="{FF2B5EF4-FFF2-40B4-BE49-F238E27FC236}">
+                <a16:creationId xmlns:a16="http://schemas.microsoft.com/office/drawing/2014/main" id="{48D3A572-CBF2-4C05-7872-854C67FD2F9D}"/>
+              </a:ext>
+            </a:extLst>
+          </p:cNvPr>
+          <p:cNvPicPr>
+            <a:picLocks noChangeAspect="1"/>
+          </p:cNvPicPr>
+          <p:nvPr/>
+        </p:nvPicPr>
+        <p:blipFill>
+          <a:blip r:embed="rId3"/>
+          <a:stretch>
+            <a:fillRect/>
+          </a:stretch>
+        </p:blipFill>
+        <p:spPr>
+          <a:xfrm>
+            <a:off x="3867150" y="288239"/>
+            <a:ext cx="1802397" cy="2527072"/>
+          </a:xfrm>
+          <a:prstGeom prst="rect">
+            <a:avLst/>
+          </a:prstGeom>
+        </p:spPr>
+      </p:pic>
+      <p:sp>
+        <p:nvSpPr>
+          <p:cNvPr id="2" name="TextBox 2">
+            <a:extLst>
+              <a:ext uri="{FF2B5EF4-FFF2-40B4-BE49-F238E27FC236}">
+                <a16:creationId xmlns:a16="http://schemas.microsoft.com/office/drawing/2014/main" id="{129229F1-D112-01B9-2DC0-65EED89C66DF}"/>
+              </a:ext>
+            </a:extLst>
+          </p:cNvPr>
+          <p:cNvSpPr txBox="1"/>
+          <p:nvPr/>
+        </p:nvSpPr>
+        <p:spPr>
+          <a:xfrm>
+            <a:off x="277092" y="277825"/>
+            <a:ext cx="2675658" cy="241476"/>
+          </a:xfrm>
+          <a:prstGeom prst="rect">
+            <a:avLst/>
+          </a:prstGeom>
+        </p:spPr>
+        <p:txBody>
+          <a:bodyPr wrap="square" lIns="0" tIns="0" rIns="0" bIns="0" rtlCol="0" anchor="t">
+            <a:spAutoFit/>
+          </a:bodyPr>
+          <a:lstStyle/>
+          <a:p>
+            <a:pPr algn="l">
+              <a:lnSpc>
+                <a:spcPts val="2100"/>
+              </a:lnSpc>
+            </a:pPr>
+            <a:r>
+              <a:rPr lang="en-US" sz="1500" b="1" spc="-4" dirty="0">
+                <a:solidFill>
+                  <a:srgbClr val="2B4D7B"/>
+                </a:solidFill>
+                <a:latin typeface="Tahoma" panose="020B0604030504040204" pitchFamily="34" charset="0"/>
+                <a:ea typeface="Tahoma" panose="020B0604030504040204" pitchFamily="34" charset="0"/>
+                <a:cs typeface="Tahoma" panose="020B0604030504040204" pitchFamily="34" charset="0"/>
+                <a:sym typeface="Canva Sans Bold"/>
+              </a:rPr>
+              <a:t>4. Phương </a:t>
+            </a:r>
+            <a:r>
+              <a:rPr lang="en-US" sz="1500" b="1" spc="-4" dirty="0" err="1">
+                <a:solidFill>
+                  <a:srgbClr val="2B4D7B"/>
+                </a:solidFill>
+                <a:latin typeface="Tahoma" panose="020B0604030504040204" pitchFamily="34" charset="0"/>
+                <a:ea typeface="Tahoma" panose="020B0604030504040204" pitchFamily="34" charset="0"/>
+                <a:cs typeface="Tahoma" panose="020B0604030504040204" pitchFamily="34" charset="0"/>
+                <a:sym typeface="Canva Sans Bold"/>
+              </a:rPr>
+              <a:t>pháp</a:t>
+            </a:r>
+            <a:endParaRPr lang="en-US" sz="1500" b="1" spc="-4" dirty="0">
+              <a:solidFill>
+                <a:srgbClr val="2B4D7B"/>
+              </a:solidFill>
+              <a:latin typeface="Tahoma" panose="020B0604030504040204" pitchFamily="34" charset="0"/>
+              <a:ea typeface="Tahoma" panose="020B0604030504040204" pitchFamily="34" charset="0"/>
+              <a:cs typeface="Tahoma" panose="020B0604030504040204" pitchFamily="34" charset="0"/>
+              <a:sym typeface="Canva Sans Bold"/>
+            </a:endParaRPr>
+          </a:p>
+        </p:txBody>
+      </p:sp>
+      <p:sp>
+        <p:nvSpPr>
+          <p:cNvPr id="10" name="TextBox 9">
+            <a:extLst>
+              <a:ext uri="{FF2B5EF4-FFF2-40B4-BE49-F238E27FC236}">
+                <a16:creationId xmlns:a16="http://schemas.microsoft.com/office/drawing/2014/main" id="{7BF2B829-B41D-7143-A7D7-50866E4D4B85}"/>
+              </a:ext>
+            </a:extLst>
+          </p:cNvPr>
+          <p:cNvSpPr txBox="1"/>
+          <p:nvPr/>
+        </p:nvSpPr>
+        <p:spPr>
+          <a:xfrm>
+            <a:off x="5314950" y="2914650"/>
+            <a:ext cx="295275" cy="215444"/>
+          </a:xfrm>
+          <a:prstGeom prst="rect">
+            <a:avLst/>
+          </a:prstGeom>
+          <a:noFill/>
+        </p:spPr>
+        <p:txBody>
+          <a:bodyPr wrap="square">
+            <a:spAutoFit/>
+          </a:bodyPr>
+          <a:lstStyle/>
+          <a:p>
+            <a:pPr algn="r"/>
+            <a:r>
+              <a:rPr lang="en-US" sz="800" dirty="0">
+                <a:solidFill>
+                  <a:srgbClr val="1C1C1A"/>
+                </a:solidFill>
+                <a:latin typeface="Tahoma" panose="020B0604030504040204" pitchFamily="34" charset="0"/>
+                <a:ea typeface="Tahoma" panose="020B0604030504040204" pitchFamily="34" charset="0"/>
+                <a:cs typeface="Tahoma" panose="020B0604030504040204" pitchFamily="34" charset="0"/>
+                <a:sym typeface="Canva Sans"/>
+              </a:rPr>
+              <a:t>16</a:t>
+            </a:r>
+            <a:endParaRPr lang="en-US" sz="800" dirty="0">
+              <a:latin typeface="Tahoma" panose="020B0604030504040204" pitchFamily="34" charset="0"/>
+              <a:ea typeface="Tahoma" panose="020B0604030504040204" pitchFamily="34" charset="0"/>
+              <a:cs typeface="Tahoma" panose="020B0604030504040204" pitchFamily="34" charset="0"/>
+            </a:endParaRPr>
+          </a:p>
+        </p:txBody>
+      </p:sp>
+      <p:sp>
+        <p:nvSpPr>
+          <p:cNvPr id="9" name="TextBox 8">
+            <a:extLst>
+              <a:ext uri="{FF2B5EF4-FFF2-40B4-BE49-F238E27FC236}">
+                <a16:creationId xmlns:a16="http://schemas.microsoft.com/office/drawing/2014/main" id="{0553F640-A8EE-DA8E-99BB-9A9CC7E19BB5}"/>
+              </a:ext>
+            </a:extLst>
+          </p:cNvPr>
+          <p:cNvSpPr txBox="1"/>
+          <p:nvPr/>
+        </p:nvSpPr>
+        <p:spPr>
+          <a:xfrm>
+            <a:off x="277092" y="519301"/>
+            <a:ext cx="2675658" cy="251094"/>
+          </a:xfrm>
+          <a:prstGeom prst="rect">
+            <a:avLst/>
+          </a:prstGeom>
+          <a:noFill/>
+        </p:spPr>
+        <p:txBody>
+          <a:bodyPr wrap="square" rtlCol="0">
+            <a:spAutoFit/>
+          </a:bodyPr>
+          <a:lstStyle/>
+          <a:p>
+            <a:pPr algn="just">
+              <a:lnSpc>
+                <a:spcPct val="130000"/>
+              </a:lnSpc>
+            </a:pPr>
+            <a:r>
+              <a:rPr lang="en-US" sz="900" u="sng" dirty="0">
+                <a:solidFill>
+                  <a:srgbClr val="00B050"/>
+                </a:solidFill>
+                <a:latin typeface="Tahoma" panose="020B0604030504040204" pitchFamily="34" charset="0"/>
+                <a:ea typeface="Tahoma" panose="020B0604030504040204" pitchFamily="34" charset="0"/>
+                <a:cs typeface="Tahoma" panose="020B0604030504040204" pitchFamily="34" charset="0"/>
+              </a:rPr>
+              <a:t>4.1. </a:t>
+            </a:r>
+            <a:r>
+              <a:rPr lang="en-US" sz="900" u="sng" dirty="0" err="1">
+                <a:solidFill>
+                  <a:srgbClr val="00B050"/>
+                </a:solidFill>
+                <a:latin typeface="Tahoma" panose="020B0604030504040204" pitchFamily="34" charset="0"/>
+                <a:ea typeface="Tahoma" panose="020B0604030504040204" pitchFamily="34" charset="0"/>
+                <a:cs typeface="Tahoma" panose="020B0604030504040204" pitchFamily="34" charset="0"/>
+              </a:rPr>
+              <a:t>Mô</a:t>
+            </a:r>
+            <a:r>
+              <a:rPr lang="en-US" sz="900" u="sng" dirty="0">
+                <a:solidFill>
+                  <a:srgbClr val="00B050"/>
+                </a:solidFill>
+                <a:latin typeface="Tahoma" panose="020B0604030504040204" pitchFamily="34" charset="0"/>
+                <a:ea typeface="Tahoma" panose="020B0604030504040204" pitchFamily="34" charset="0"/>
+                <a:cs typeface="Tahoma" panose="020B0604030504040204" pitchFamily="34" charset="0"/>
+              </a:rPr>
+              <a:t> </a:t>
+            </a:r>
+            <a:r>
+              <a:rPr lang="en-US" sz="900" u="sng" dirty="0" err="1">
+                <a:solidFill>
+                  <a:srgbClr val="00B050"/>
+                </a:solidFill>
+                <a:latin typeface="Tahoma" panose="020B0604030504040204" pitchFamily="34" charset="0"/>
+                <a:ea typeface="Tahoma" panose="020B0604030504040204" pitchFamily="34" charset="0"/>
+                <a:cs typeface="Tahoma" panose="020B0604030504040204" pitchFamily="34" charset="0"/>
+              </a:rPr>
+              <a:t>hình</a:t>
+            </a:r>
+            <a:r>
+              <a:rPr lang="en-US" sz="900" u="sng" dirty="0">
+                <a:solidFill>
+                  <a:srgbClr val="00B050"/>
+                </a:solidFill>
+                <a:latin typeface="Tahoma" panose="020B0604030504040204" pitchFamily="34" charset="0"/>
+                <a:ea typeface="Tahoma" panose="020B0604030504040204" pitchFamily="34" charset="0"/>
+                <a:cs typeface="Tahoma" panose="020B0604030504040204" pitchFamily="34" charset="0"/>
+              </a:rPr>
+              <a:t> Transformer</a:t>
+            </a:r>
+            <a:endParaRPr lang="vi-VN" sz="900" u="sng" dirty="0">
+              <a:solidFill>
+                <a:srgbClr val="00B050"/>
+              </a:solidFill>
+              <a:latin typeface="Tahoma" panose="020B0604030504040204" pitchFamily="34" charset="0"/>
+              <a:ea typeface="Tahoma" panose="020B0604030504040204" pitchFamily="34" charset="0"/>
+              <a:cs typeface="Tahoma" panose="020B0604030504040204" pitchFamily="34" charset="0"/>
+            </a:endParaRPr>
+          </a:p>
+        </p:txBody>
+      </p:sp>
+      <p:sp>
+        <p:nvSpPr>
+          <p:cNvPr id="3" name="TextBox 2">
+            <a:extLst>
+              <a:ext uri="{FF2B5EF4-FFF2-40B4-BE49-F238E27FC236}">
+                <a16:creationId xmlns:a16="http://schemas.microsoft.com/office/drawing/2014/main" id="{0D645298-74A0-F713-AB39-8FDF133FE67E}"/>
+              </a:ext>
+            </a:extLst>
+          </p:cNvPr>
+          <p:cNvSpPr txBox="1"/>
+          <p:nvPr/>
+        </p:nvSpPr>
+        <p:spPr>
+          <a:xfrm>
+            <a:off x="277092" y="760777"/>
+            <a:ext cx="3513858" cy="2313967"/>
+          </a:xfrm>
+          <a:prstGeom prst="rect">
+            <a:avLst/>
+          </a:prstGeom>
+          <a:noFill/>
+        </p:spPr>
+        <p:txBody>
+          <a:bodyPr wrap="square" rtlCol="0">
+            <a:spAutoFit/>
+          </a:bodyPr>
+          <a:lstStyle/>
+          <a:p>
+            <a:pPr algn="just">
+              <a:lnSpc>
+                <a:spcPct val="130000"/>
+              </a:lnSpc>
+            </a:pPr>
+            <a:r>
+              <a:rPr lang="en-US" sz="800" dirty="0">
+                <a:latin typeface="Tahoma" panose="020B0604030504040204" pitchFamily="34" charset="0"/>
+                <a:ea typeface="Tahoma" panose="020B0604030504040204" pitchFamily="34" charset="0"/>
+                <a:cs typeface="Tahoma" panose="020B0604030504040204" pitchFamily="34" charset="0"/>
+              </a:rPr>
+              <a:t>Transformer </a:t>
+            </a:r>
+            <a:r>
+              <a:rPr lang="en-US" sz="800" dirty="0" err="1">
+                <a:latin typeface="Tahoma" panose="020B0604030504040204" pitchFamily="34" charset="0"/>
+                <a:ea typeface="Tahoma" panose="020B0604030504040204" pitchFamily="34" charset="0"/>
+                <a:cs typeface="Tahoma" panose="020B0604030504040204" pitchFamily="34" charset="0"/>
+              </a:rPr>
+              <a:t>là</a:t>
+            </a:r>
+            <a:r>
+              <a:rPr lang="en-US" sz="800" dirty="0">
+                <a:latin typeface="Tahoma" panose="020B0604030504040204" pitchFamily="34" charset="0"/>
+                <a:ea typeface="Tahoma" panose="020B0604030504040204" pitchFamily="34" charset="0"/>
+                <a:cs typeface="Tahoma" panose="020B0604030504040204" pitchFamily="34" charset="0"/>
+              </a:rPr>
+              <a:t> </a:t>
+            </a:r>
+            <a:r>
+              <a:rPr lang="en-US" sz="800" dirty="0" err="1">
+                <a:latin typeface="Tahoma" panose="020B0604030504040204" pitchFamily="34" charset="0"/>
+                <a:ea typeface="Tahoma" panose="020B0604030504040204" pitchFamily="34" charset="0"/>
+                <a:cs typeface="Tahoma" panose="020B0604030504040204" pitchFamily="34" charset="0"/>
+              </a:rPr>
+              <a:t>mô</a:t>
+            </a:r>
+            <a:r>
+              <a:rPr lang="en-US" sz="800" dirty="0">
+                <a:latin typeface="Tahoma" panose="020B0604030504040204" pitchFamily="34" charset="0"/>
+                <a:ea typeface="Tahoma" panose="020B0604030504040204" pitchFamily="34" charset="0"/>
+                <a:cs typeface="Tahoma" panose="020B0604030504040204" pitchFamily="34" charset="0"/>
+              </a:rPr>
+              <a:t> </a:t>
+            </a:r>
+            <a:r>
+              <a:rPr lang="en-US" sz="800" dirty="0" err="1">
+                <a:latin typeface="Tahoma" panose="020B0604030504040204" pitchFamily="34" charset="0"/>
+                <a:ea typeface="Tahoma" panose="020B0604030504040204" pitchFamily="34" charset="0"/>
+                <a:cs typeface="Tahoma" panose="020B0604030504040204" pitchFamily="34" charset="0"/>
+              </a:rPr>
+              <a:t>hình</a:t>
+            </a:r>
+            <a:r>
+              <a:rPr lang="en-US" sz="800" dirty="0">
+                <a:latin typeface="Tahoma" panose="020B0604030504040204" pitchFamily="34" charset="0"/>
+                <a:ea typeface="Tahoma" panose="020B0604030504040204" pitchFamily="34" charset="0"/>
+                <a:cs typeface="Tahoma" panose="020B0604030504040204" pitchFamily="34" charset="0"/>
+              </a:rPr>
+              <a:t> Encoder–Decoder </a:t>
+            </a:r>
+            <a:r>
+              <a:rPr lang="en-US" sz="800" dirty="0" err="1">
+                <a:latin typeface="Tahoma" panose="020B0604030504040204" pitchFamily="34" charset="0"/>
+                <a:ea typeface="Tahoma" panose="020B0604030504040204" pitchFamily="34" charset="0"/>
+                <a:cs typeface="Tahoma" panose="020B0604030504040204" pitchFamily="34" charset="0"/>
+              </a:rPr>
+              <a:t>dựa</a:t>
+            </a:r>
+            <a:r>
+              <a:rPr lang="en-US" sz="800" dirty="0">
+                <a:latin typeface="Tahoma" panose="020B0604030504040204" pitchFamily="34" charset="0"/>
+                <a:ea typeface="Tahoma" panose="020B0604030504040204" pitchFamily="34" charset="0"/>
+                <a:cs typeface="Tahoma" panose="020B0604030504040204" pitchFamily="34" charset="0"/>
+              </a:rPr>
+              <a:t> </a:t>
+            </a:r>
+            <a:r>
+              <a:rPr lang="en-US" sz="800" dirty="0" err="1">
+                <a:latin typeface="Tahoma" panose="020B0604030504040204" pitchFamily="34" charset="0"/>
+                <a:ea typeface="Tahoma" panose="020B0604030504040204" pitchFamily="34" charset="0"/>
+                <a:cs typeface="Tahoma" panose="020B0604030504040204" pitchFamily="34" charset="0"/>
+              </a:rPr>
+              <a:t>hoàn</a:t>
+            </a:r>
+            <a:r>
+              <a:rPr lang="en-US" sz="800" dirty="0">
+                <a:latin typeface="Tahoma" panose="020B0604030504040204" pitchFamily="34" charset="0"/>
+                <a:ea typeface="Tahoma" panose="020B0604030504040204" pitchFamily="34" charset="0"/>
+                <a:cs typeface="Tahoma" panose="020B0604030504040204" pitchFamily="34" charset="0"/>
+              </a:rPr>
+              <a:t> </a:t>
+            </a:r>
+            <a:r>
+              <a:rPr lang="en-US" sz="800" dirty="0" err="1">
+                <a:latin typeface="Tahoma" panose="020B0604030504040204" pitchFamily="34" charset="0"/>
+                <a:ea typeface="Tahoma" panose="020B0604030504040204" pitchFamily="34" charset="0"/>
+                <a:cs typeface="Tahoma" panose="020B0604030504040204" pitchFamily="34" charset="0"/>
+              </a:rPr>
+              <a:t>toàn</a:t>
+            </a:r>
+            <a:r>
+              <a:rPr lang="en-US" sz="800" dirty="0">
+                <a:latin typeface="Tahoma" panose="020B0604030504040204" pitchFamily="34" charset="0"/>
+                <a:ea typeface="Tahoma" panose="020B0604030504040204" pitchFamily="34" charset="0"/>
+                <a:cs typeface="Tahoma" panose="020B0604030504040204" pitchFamily="34" charset="0"/>
+              </a:rPr>
+              <a:t> </a:t>
+            </a:r>
+            <a:r>
+              <a:rPr lang="en-US" sz="800" dirty="0" err="1">
+                <a:latin typeface="Tahoma" panose="020B0604030504040204" pitchFamily="34" charset="0"/>
+                <a:ea typeface="Tahoma" panose="020B0604030504040204" pitchFamily="34" charset="0"/>
+                <a:cs typeface="Tahoma" panose="020B0604030504040204" pitchFamily="34" charset="0"/>
+              </a:rPr>
+              <a:t>trên</a:t>
+            </a:r>
+            <a:r>
+              <a:rPr lang="en-US" sz="800" dirty="0">
+                <a:latin typeface="Tahoma" panose="020B0604030504040204" pitchFamily="34" charset="0"/>
+                <a:ea typeface="Tahoma" panose="020B0604030504040204" pitchFamily="34" charset="0"/>
+                <a:cs typeface="Tahoma" panose="020B0604030504040204" pitchFamily="34" charset="0"/>
+              </a:rPr>
+              <a:t> Attention, </a:t>
+            </a:r>
+            <a:r>
+              <a:rPr lang="en-US" sz="800" dirty="0" err="1">
+                <a:latin typeface="Tahoma" panose="020B0604030504040204" pitchFamily="34" charset="0"/>
+                <a:ea typeface="Tahoma" panose="020B0604030504040204" pitchFamily="34" charset="0"/>
+                <a:cs typeface="Tahoma" panose="020B0604030504040204" pitchFamily="34" charset="0"/>
+              </a:rPr>
+              <a:t>không</a:t>
+            </a:r>
+            <a:r>
+              <a:rPr lang="en-US" sz="800" dirty="0">
+                <a:latin typeface="Tahoma" panose="020B0604030504040204" pitchFamily="34" charset="0"/>
+                <a:ea typeface="Tahoma" panose="020B0604030504040204" pitchFamily="34" charset="0"/>
+                <a:cs typeface="Tahoma" panose="020B0604030504040204" pitchFamily="34" charset="0"/>
+              </a:rPr>
+              <a:t> </a:t>
+            </a:r>
+            <a:r>
+              <a:rPr lang="en-US" sz="800" dirty="0" err="1">
+                <a:latin typeface="Tahoma" panose="020B0604030504040204" pitchFamily="34" charset="0"/>
+                <a:ea typeface="Tahoma" panose="020B0604030504040204" pitchFamily="34" charset="0"/>
+                <a:cs typeface="Tahoma" panose="020B0604030504040204" pitchFamily="34" charset="0"/>
+              </a:rPr>
+              <a:t>sử</a:t>
+            </a:r>
+            <a:r>
+              <a:rPr lang="en-US" sz="800" dirty="0">
+                <a:latin typeface="Tahoma" panose="020B0604030504040204" pitchFamily="34" charset="0"/>
+                <a:ea typeface="Tahoma" panose="020B0604030504040204" pitchFamily="34" charset="0"/>
+                <a:cs typeface="Tahoma" panose="020B0604030504040204" pitchFamily="34" charset="0"/>
+              </a:rPr>
+              <a:t> </a:t>
+            </a:r>
+            <a:r>
+              <a:rPr lang="en-US" sz="800" dirty="0" err="1">
+                <a:latin typeface="Tahoma" panose="020B0604030504040204" pitchFamily="34" charset="0"/>
+                <a:ea typeface="Tahoma" panose="020B0604030504040204" pitchFamily="34" charset="0"/>
+                <a:cs typeface="Tahoma" panose="020B0604030504040204" pitchFamily="34" charset="0"/>
+              </a:rPr>
+              <a:t>dụng</a:t>
+            </a:r>
+            <a:r>
+              <a:rPr lang="en-US" sz="800" dirty="0">
+                <a:latin typeface="Tahoma" panose="020B0604030504040204" pitchFamily="34" charset="0"/>
+                <a:ea typeface="Tahoma" panose="020B0604030504040204" pitchFamily="34" charset="0"/>
+                <a:cs typeface="Tahoma" panose="020B0604030504040204" pitchFamily="34" charset="0"/>
+              </a:rPr>
+              <a:t> RNN.</a:t>
+            </a:r>
+          </a:p>
+          <a:p>
+            <a:pPr algn="just">
+              <a:lnSpc>
+                <a:spcPct val="130000"/>
+              </a:lnSpc>
+            </a:pPr>
+            <a:r>
+              <a:rPr lang="en-US" sz="800" dirty="0">
+                <a:latin typeface="Tahoma" panose="020B0604030504040204" pitchFamily="34" charset="0"/>
+                <a:ea typeface="Tahoma" panose="020B0604030504040204" pitchFamily="34" charset="0"/>
+                <a:cs typeface="Tahoma" panose="020B0604030504040204" pitchFamily="34" charset="0"/>
+              </a:rPr>
+              <a:t>→ Cho </a:t>
+            </a:r>
+            <a:r>
+              <a:rPr lang="en-US" sz="800" dirty="0" err="1">
+                <a:latin typeface="Tahoma" panose="020B0604030504040204" pitchFamily="34" charset="0"/>
+                <a:ea typeface="Tahoma" panose="020B0604030504040204" pitchFamily="34" charset="0"/>
+                <a:cs typeface="Tahoma" panose="020B0604030504040204" pitchFamily="34" charset="0"/>
+              </a:rPr>
+              <a:t>phép</a:t>
+            </a:r>
+            <a:r>
+              <a:rPr lang="en-US" sz="800" dirty="0">
+                <a:latin typeface="Tahoma" panose="020B0604030504040204" pitchFamily="34" charset="0"/>
+                <a:ea typeface="Tahoma" panose="020B0604030504040204" pitchFamily="34" charset="0"/>
+                <a:cs typeface="Tahoma" panose="020B0604030504040204" pitchFamily="34" charset="0"/>
+              </a:rPr>
+              <a:t> </a:t>
+            </a:r>
+            <a:r>
+              <a:rPr lang="en-US" sz="800" dirty="0" err="1">
+                <a:latin typeface="Tahoma" panose="020B0604030504040204" pitchFamily="34" charset="0"/>
+                <a:ea typeface="Tahoma" panose="020B0604030504040204" pitchFamily="34" charset="0"/>
+                <a:cs typeface="Tahoma" panose="020B0604030504040204" pitchFamily="34" charset="0"/>
+              </a:rPr>
+              <a:t>xử</a:t>
+            </a:r>
+            <a:r>
+              <a:rPr lang="en-US" sz="800" dirty="0">
+                <a:latin typeface="Tahoma" panose="020B0604030504040204" pitchFamily="34" charset="0"/>
+                <a:ea typeface="Tahoma" panose="020B0604030504040204" pitchFamily="34" charset="0"/>
+                <a:cs typeface="Tahoma" panose="020B0604030504040204" pitchFamily="34" charset="0"/>
+              </a:rPr>
+              <a:t> </a:t>
+            </a:r>
+            <a:r>
+              <a:rPr lang="en-US" sz="800" dirty="0" err="1">
+                <a:latin typeface="Tahoma" panose="020B0604030504040204" pitchFamily="34" charset="0"/>
+                <a:ea typeface="Tahoma" panose="020B0604030504040204" pitchFamily="34" charset="0"/>
+                <a:cs typeface="Tahoma" panose="020B0604030504040204" pitchFamily="34" charset="0"/>
+              </a:rPr>
+              <a:t>lý</a:t>
+            </a:r>
+            <a:r>
+              <a:rPr lang="en-US" sz="800" dirty="0">
+                <a:latin typeface="Tahoma" panose="020B0604030504040204" pitchFamily="34" charset="0"/>
+                <a:ea typeface="Tahoma" panose="020B0604030504040204" pitchFamily="34" charset="0"/>
+                <a:cs typeface="Tahoma" panose="020B0604030504040204" pitchFamily="34" charset="0"/>
+              </a:rPr>
+              <a:t> song </a:t>
+            </a:r>
+            <a:r>
+              <a:rPr lang="en-US" sz="800" dirty="0" err="1">
+                <a:latin typeface="Tahoma" panose="020B0604030504040204" pitchFamily="34" charset="0"/>
+                <a:ea typeface="Tahoma" panose="020B0604030504040204" pitchFamily="34" charset="0"/>
+                <a:cs typeface="Tahoma" panose="020B0604030504040204" pitchFamily="34" charset="0"/>
+              </a:rPr>
+              <a:t>song</a:t>
+            </a:r>
+            <a:r>
+              <a:rPr lang="en-US" sz="800" dirty="0">
+                <a:latin typeface="Tahoma" panose="020B0604030504040204" pitchFamily="34" charset="0"/>
+                <a:ea typeface="Tahoma" panose="020B0604030504040204" pitchFamily="34" charset="0"/>
+                <a:cs typeface="Tahoma" panose="020B0604030504040204" pitchFamily="34" charset="0"/>
+              </a:rPr>
+              <a:t> </a:t>
+            </a:r>
+            <a:r>
+              <a:rPr lang="en-US" sz="800" dirty="0" err="1">
+                <a:latin typeface="Tahoma" panose="020B0604030504040204" pitchFamily="34" charset="0"/>
+                <a:ea typeface="Tahoma" panose="020B0604030504040204" pitchFamily="34" charset="0"/>
+                <a:cs typeface="Tahoma" panose="020B0604030504040204" pitchFamily="34" charset="0"/>
+              </a:rPr>
+              <a:t>và</a:t>
+            </a:r>
+            <a:r>
+              <a:rPr lang="en-US" sz="800" dirty="0">
+                <a:latin typeface="Tahoma" panose="020B0604030504040204" pitchFamily="34" charset="0"/>
+                <a:ea typeface="Tahoma" panose="020B0604030504040204" pitchFamily="34" charset="0"/>
+                <a:cs typeface="Tahoma" panose="020B0604030504040204" pitchFamily="34" charset="0"/>
+              </a:rPr>
+              <a:t> </a:t>
+            </a:r>
+            <a:r>
+              <a:rPr lang="en-US" sz="800" dirty="0" err="1">
+                <a:latin typeface="Tahoma" panose="020B0604030504040204" pitchFamily="34" charset="0"/>
+                <a:ea typeface="Tahoma" panose="020B0604030504040204" pitchFamily="34" charset="0"/>
+                <a:cs typeface="Tahoma" panose="020B0604030504040204" pitchFamily="34" charset="0"/>
+              </a:rPr>
+              <a:t>học</a:t>
+            </a:r>
+            <a:r>
+              <a:rPr lang="en-US" sz="800" dirty="0">
+                <a:latin typeface="Tahoma" panose="020B0604030504040204" pitchFamily="34" charset="0"/>
+                <a:ea typeface="Tahoma" panose="020B0604030504040204" pitchFamily="34" charset="0"/>
+                <a:cs typeface="Tahoma" panose="020B0604030504040204" pitchFamily="34" charset="0"/>
+              </a:rPr>
+              <a:t> </a:t>
+            </a:r>
+            <a:r>
+              <a:rPr lang="en-US" sz="800" dirty="0" err="1">
+                <a:latin typeface="Tahoma" panose="020B0604030504040204" pitchFamily="34" charset="0"/>
+                <a:ea typeface="Tahoma" panose="020B0604030504040204" pitchFamily="34" charset="0"/>
+                <a:cs typeface="Tahoma" panose="020B0604030504040204" pitchFamily="34" charset="0"/>
+              </a:rPr>
+              <a:t>tốt</a:t>
+            </a:r>
+            <a:r>
+              <a:rPr lang="en-US" sz="800" dirty="0">
+                <a:latin typeface="Tahoma" panose="020B0604030504040204" pitchFamily="34" charset="0"/>
+                <a:ea typeface="Tahoma" panose="020B0604030504040204" pitchFamily="34" charset="0"/>
+                <a:cs typeface="Tahoma" panose="020B0604030504040204" pitchFamily="34" charset="0"/>
+              </a:rPr>
+              <a:t> </a:t>
+            </a:r>
+            <a:r>
+              <a:rPr lang="en-US" sz="800" dirty="0" err="1">
+                <a:latin typeface="Tahoma" panose="020B0604030504040204" pitchFamily="34" charset="0"/>
+                <a:ea typeface="Tahoma" panose="020B0604030504040204" pitchFamily="34" charset="0"/>
+                <a:cs typeface="Tahoma" panose="020B0604030504040204" pitchFamily="34" charset="0"/>
+              </a:rPr>
+              <a:t>các</a:t>
+            </a:r>
+            <a:r>
+              <a:rPr lang="en-US" sz="800" dirty="0">
+                <a:latin typeface="Tahoma" panose="020B0604030504040204" pitchFamily="34" charset="0"/>
+                <a:ea typeface="Tahoma" panose="020B0604030504040204" pitchFamily="34" charset="0"/>
+                <a:cs typeface="Tahoma" panose="020B0604030504040204" pitchFamily="34" charset="0"/>
+              </a:rPr>
+              <a:t> </a:t>
+            </a:r>
+            <a:r>
+              <a:rPr lang="en-US" sz="800" dirty="0" err="1">
+                <a:latin typeface="Tahoma" panose="020B0604030504040204" pitchFamily="34" charset="0"/>
+                <a:ea typeface="Tahoma" panose="020B0604030504040204" pitchFamily="34" charset="0"/>
+                <a:cs typeface="Tahoma" panose="020B0604030504040204" pitchFamily="34" charset="0"/>
+              </a:rPr>
+              <a:t>phụ</a:t>
+            </a:r>
+            <a:r>
+              <a:rPr lang="en-US" sz="800" dirty="0">
+                <a:latin typeface="Tahoma" panose="020B0604030504040204" pitchFamily="34" charset="0"/>
+                <a:ea typeface="Tahoma" panose="020B0604030504040204" pitchFamily="34" charset="0"/>
+                <a:cs typeface="Tahoma" panose="020B0604030504040204" pitchFamily="34" charset="0"/>
+              </a:rPr>
+              <a:t> </a:t>
+            </a:r>
+            <a:r>
+              <a:rPr lang="en-US" sz="800" dirty="0" err="1">
+                <a:latin typeface="Tahoma" panose="020B0604030504040204" pitchFamily="34" charset="0"/>
+                <a:ea typeface="Tahoma" panose="020B0604030504040204" pitchFamily="34" charset="0"/>
+                <a:cs typeface="Tahoma" panose="020B0604030504040204" pitchFamily="34" charset="0"/>
+              </a:rPr>
+              <a:t>thuộc</a:t>
+            </a:r>
+            <a:r>
+              <a:rPr lang="en-US" sz="800" dirty="0">
+                <a:latin typeface="Tahoma" panose="020B0604030504040204" pitchFamily="34" charset="0"/>
+                <a:ea typeface="Tahoma" panose="020B0604030504040204" pitchFamily="34" charset="0"/>
+                <a:cs typeface="Tahoma" panose="020B0604030504040204" pitchFamily="34" charset="0"/>
+              </a:rPr>
+              <a:t> </a:t>
+            </a:r>
+            <a:r>
+              <a:rPr lang="en-US" sz="800" dirty="0" err="1">
+                <a:latin typeface="Tahoma" panose="020B0604030504040204" pitchFamily="34" charset="0"/>
+                <a:ea typeface="Tahoma" panose="020B0604030504040204" pitchFamily="34" charset="0"/>
+                <a:cs typeface="Tahoma" panose="020B0604030504040204" pitchFamily="34" charset="0"/>
+              </a:rPr>
+              <a:t>dài</a:t>
+            </a:r>
+            <a:r>
+              <a:rPr lang="en-US" sz="800" dirty="0">
+                <a:latin typeface="Tahoma" panose="020B0604030504040204" pitchFamily="34" charset="0"/>
+                <a:ea typeface="Tahoma" panose="020B0604030504040204" pitchFamily="34" charset="0"/>
+                <a:cs typeface="Tahoma" panose="020B0604030504040204" pitchFamily="34" charset="0"/>
+              </a:rPr>
+              <a:t> </a:t>
+            </a:r>
+            <a:r>
+              <a:rPr lang="en-US" sz="800" dirty="0" err="1">
+                <a:latin typeface="Tahoma" panose="020B0604030504040204" pitchFamily="34" charset="0"/>
+                <a:ea typeface="Tahoma" panose="020B0604030504040204" pitchFamily="34" charset="0"/>
+                <a:cs typeface="Tahoma" panose="020B0604030504040204" pitchFamily="34" charset="0"/>
+              </a:rPr>
+              <a:t>hạn</a:t>
+            </a:r>
+            <a:r>
+              <a:rPr lang="en-US" sz="800" dirty="0">
+                <a:latin typeface="Tahoma" panose="020B0604030504040204" pitchFamily="34" charset="0"/>
+                <a:ea typeface="Tahoma" panose="020B0604030504040204" pitchFamily="34" charset="0"/>
+                <a:cs typeface="Tahoma" panose="020B0604030504040204" pitchFamily="34" charset="0"/>
+              </a:rPr>
+              <a:t> </a:t>
+            </a:r>
+            <a:r>
+              <a:rPr lang="en-US" sz="800" dirty="0" err="1">
+                <a:latin typeface="Tahoma" panose="020B0604030504040204" pitchFamily="34" charset="0"/>
+                <a:ea typeface="Tahoma" panose="020B0604030504040204" pitchFamily="34" charset="0"/>
+                <a:cs typeface="Tahoma" panose="020B0604030504040204" pitchFamily="34" charset="0"/>
+              </a:rPr>
+              <a:t>trong</a:t>
+            </a:r>
+            <a:r>
+              <a:rPr lang="en-US" sz="800" dirty="0">
+                <a:latin typeface="Tahoma" panose="020B0604030504040204" pitchFamily="34" charset="0"/>
+                <a:ea typeface="Tahoma" panose="020B0604030504040204" pitchFamily="34" charset="0"/>
+                <a:cs typeface="Tahoma" panose="020B0604030504040204" pitchFamily="34" charset="0"/>
+              </a:rPr>
+              <a:t> </a:t>
+            </a:r>
+            <a:r>
+              <a:rPr lang="en-US" sz="800" dirty="0" err="1">
+                <a:latin typeface="Tahoma" panose="020B0604030504040204" pitchFamily="34" charset="0"/>
+                <a:ea typeface="Tahoma" panose="020B0604030504040204" pitchFamily="34" charset="0"/>
+                <a:cs typeface="Tahoma" panose="020B0604030504040204" pitchFamily="34" charset="0"/>
+              </a:rPr>
+              <a:t>câu</a:t>
+            </a:r>
+            <a:r>
+              <a:rPr lang="en-US" sz="800" dirty="0">
+                <a:latin typeface="Tahoma" panose="020B0604030504040204" pitchFamily="34" charset="0"/>
+                <a:ea typeface="Tahoma" panose="020B0604030504040204" pitchFamily="34" charset="0"/>
+                <a:cs typeface="Tahoma" panose="020B0604030504040204" pitchFamily="34" charset="0"/>
+              </a:rPr>
+              <a:t>.</a:t>
+            </a:r>
+          </a:p>
+          <a:p>
+            <a:pPr algn="just">
+              <a:lnSpc>
+                <a:spcPct val="130000"/>
+              </a:lnSpc>
+            </a:pPr>
+            <a:endParaRPr lang="en-US" sz="800" dirty="0">
+              <a:latin typeface="Tahoma" panose="020B0604030504040204" pitchFamily="34" charset="0"/>
+              <a:ea typeface="Tahoma" panose="020B0604030504040204" pitchFamily="34" charset="0"/>
+              <a:cs typeface="Tahoma" panose="020B0604030504040204" pitchFamily="34" charset="0"/>
+            </a:endParaRPr>
+          </a:p>
+          <a:p>
+            <a:pPr algn="just">
+              <a:lnSpc>
+                <a:spcPct val="130000"/>
+              </a:lnSpc>
+            </a:pPr>
+            <a:r>
+              <a:rPr lang="vi-VN" sz="800" dirty="0">
+                <a:latin typeface="Tahoma" panose="020B0604030504040204" pitchFamily="34" charset="0"/>
+                <a:ea typeface="Tahoma" panose="020B0604030504040204" pitchFamily="34" charset="0"/>
+                <a:cs typeface="Tahoma" panose="020B0604030504040204" pitchFamily="34" charset="0"/>
+              </a:rPr>
+              <a:t>Kiến trúc Transformer gồm Encoder và Decoder, cùng với các thành phần chính sau:</a:t>
+            </a:r>
+            <a:endParaRPr lang="en-US" sz="800" dirty="0">
+              <a:latin typeface="Tahoma" panose="020B0604030504040204" pitchFamily="34" charset="0"/>
+              <a:ea typeface="Tahoma" panose="020B0604030504040204" pitchFamily="34" charset="0"/>
+              <a:cs typeface="Tahoma" panose="020B0604030504040204" pitchFamily="34" charset="0"/>
+            </a:endParaRPr>
+          </a:p>
+          <a:p>
+            <a:pPr marL="285750" indent="-171450" algn="just">
+              <a:lnSpc>
+                <a:spcPct val="130000"/>
+              </a:lnSpc>
+              <a:buFont typeface="Arial" panose="020B0604020202020204" pitchFamily="34" charset="0"/>
+              <a:buChar char="•"/>
+            </a:pPr>
+            <a:r>
+              <a:rPr lang="vi-VN" sz="800" dirty="0">
+                <a:latin typeface="Tahoma" panose="020B0604030504040204" pitchFamily="34" charset="0"/>
+                <a:ea typeface="Tahoma" panose="020B0604030504040204" pitchFamily="34" charset="0"/>
+                <a:cs typeface="Tahoma" panose="020B0604030504040204" pitchFamily="34" charset="0"/>
+              </a:rPr>
+              <a:t>Positional Encoding: bổ sung thông tin vị trí của từ trong câu trước khi đưa vào Encoder</a:t>
+            </a:r>
+            <a:endParaRPr lang="en-US" sz="800" dirty="0">
+              <a:latin typeface="Tahoma" panose="020B0604030504040204" pitchFamily="34" charset="0"/>
+              <a:ea typeface="Tahoma" panose="020B0604030504040204" pitchFamily="34" charset="0"/>
+              <a:cs typeface="Tahoma" panose="020B0604030504040204" pitchFamily="34" charset="0"/>
+            </a:endParaRPr>
+          </a:p>
+          <a:p>
+            <a:pPr marL="285750" indent="-171450" algn="just">
+              <a:lnSpc>
+                <a:spcPct val="130000"/>
+              </a:lnSpc>
+              <a:buFont typeface="Arial" panose="020B0604020202020204" pitchFamily="34" charset="0"/>
+              <a:buChar char="•"/>
+            </a:pPr>
+            <a:r>
+              <a:rPr lang="vi-VN" sz="800" dirty="0">
+                <a:latin typeface="Tahoma" panose="020B0604030504040204" pitchFamily="34" charset="0"/>
+                <a:ea typeface="Tahoma" panose="020B0604030504040204" pitchFamily="34" charset="0"/>
+                <a:cs typeface="Tahoma" panose="020B0604030504040204" pitchFamily="34" charset="0"/>
+              </a:rPr>
+              <a:t>Self-Attention: mỗi từ có thể liên hệ với toàn bộ các từ còn lại để học ngữ cảnh</a:t>
+            </a:r>
+            <a:endParaRPr lang="en-US" sz="800" dirty="0">
+              <a:latin typeface="Tahoma" panose="020B0604030504040204" pitchFamily="34" charset="0"/>
+              <a:ea typeface="Tahoma" panose="020B0604030504040204" pitchFamily="34" charset="0"/>
+              <a:cs typeface="Tahoma" panose="020B0604030504040204" pitchFamily="34" charset="0"/>
+            </a:endParaRPr>
+          </a:p>
+          <a:p>
+            <a:pPr marL="285750" indent="-171450" algn="just">
+              <a:lnSpc>
+                <a:spcPct val="130000"/>
+              </a:lnSpc>
+              <a:buFont typeface="Arial" panose="020B0604020202020204" pitchFamily="34" charset="0"/>
+              <a:buChar char="•"/>
+            </a:pPr>
+            <a:r>
+              <a:rPr lang="vi-VN" sz="800" dirty="0">
+                <a:latin typeface="Tahoma" panose="020B0604030504040204" pitchFamily="34" charset="0"/>
+                <a:ea typeface="Tahoma" panose="020B0604030504040204" pitchFamily="34" charset="0"/>
+                <a:cs typeface="Tahoma" panose="020B0604030504040204" pitchFamily="34" charset="0"/>
+              </a:rPr>
+              <a:t>Multi-Head Attention: nhiều cơ chế attention song song, giúp học nhiều kiểu quan hệ khác nhau</a:t>
+            </a:r>
+            <a:endParaRPr lang="en-US" sz="800" dirty="0">
+              <a:latin typeface="Tahoma" panose="020B0604030504040204" pitchFamily="34" charset="0"/>
+              <a:ea typeface="Tahoma" panose="020B0604030504040204" pitchFamily="34" charset="0"/>
+              <a:cs typeface="Tahoma" panose="020B0604030504040204" pitchFamily="34" charset="0"/>
+            </a:endParaRPr>
+          </a:p>
+          <a:p>
+            <a:pPr marL="285750" indent="-171450" algn="just">
+              <a:lnSpc>
+                <a:spcPct val="130000"/>
+              </a:lnSpc>
+              <a:buFont typeface="Arial" panose="020B0604020202020204" pitchFamily="34" charset="0"/>
+              <a:buChar char="•"/>
+            </a:pPr>
+            <a:r>
+              <a:rPr lang="vi-VN" sz="800" dirty="0">
+                <a:latin typeface="Tahoma" panose="020B0604030504040204" pitchFamily="34" charset="0"/>
+                <a:ea typeface="Tahoma" panose="020B0604030504040204" pitchFamily="34" charset="0"/>
+                <a:cs typeface="Tahoma" panose="020B0604030504040204" pitchFamily="34" charset="0"/>
+              </a:rPr>
+              <a:t>Masking (Decoder): che thông tin tương lai, đảm bảo quá trình sinh chuỗi diễn ra theo thứ tự từ trái → phải</a:t>
+            </a:r>
+          </a:p>
+        </p:txBody>
+      </p:sp>
+    </p:spTree>
+    <p:extLst>
+      <p:ext uri="{BB962C8B-B14F-4D97-AF65-F5344CB8AC3E}">
+        <p14:creationId xmlns:p14="http://schemas.microsoft.com/office/powerpoint/2010/main" val="3385537471"/>
+      </p:ext>
+    </p:extLst>
+  </p:cSld>
+  <p:clrMapOvr>
+    <a:masterClrMapping/>
+  </p:clrMapOvr>
+</p:sld>
+</file>
+
+<file path=ppt/slides/slide18.xml><?xml version="1.0" encoding="utf-8"?>
 <p:sld xmlns:a="http://schemas.openxmlformats.org/drawingml/2006/main" xmlns:r="http://schemas.openxmlformats.org/officeDocument/2006/relationships" xmlns:p="http://schemas.openxmlformats.org/presentationml/2006/main">
   <p:cSld>
     <p:spTree>
@@ -7862,7 +9545,7 @@
 </p:sld>
 </file>
 
-<file path=ppt/slides/slide17.xml><?xml version="1.0" encoding="utf-8"?>
+<file path=ppt/slides/slide19.xml><?xml version="1.0" encoding="utf-8"?>
 <p:sld xmlns:a="http://schemas.openxmlformats.org/drawingml/2006/main" xmlns:r="http://schemas.openxmlformats.org/officeDocument/2006/relationships" xmlns:p="http://schemas.openxmlformats.org/presentationml/2006/main">
   <p:cSld>
     <p:spTree>
@@ -8185,7 +9868,590 @@
 </p:sld>
 </file>
 
-<file path=ppt/slides/slide18.xml><?xml version="1.0" encoding="utf-8"?>
+<file path=ppt/slides/slide2.xml><?xml version="1.0" encoding="utf-8"?>
+<p:sld xmlns:a="http://schemas.openxmlformats.org/drawingml/2006/main" xmlns:r="http://schemas.openxmlformats.org/officeDocument/2006/relationships" xmlns:p="http://schemas.openxmlformats.org/presentationml/2006/main">
+  <p:cSld>
+    <p:bg>
+      <p:bgPr>
+        <a:solidFill>
+          <a:srgbClr val="F4F8FF"/>
+        </a:solidFill>
+        <a:effectLst/>
+      </p:bgPr>
+    </p:bg>
+    <p:spTree>
+      <p:nvGrpSpPr>
+        <p:cNvPr id="1" name=""/>
+        <p:cNvGrpSpPr/>
+        <p:nvPr/>
+      </p:nvGrpSpPr>
+      <p:grpSpPr>
+        <a:xfrm>
+          <a:off x="0" y="0"/>
+          <a:ext cx="0" cy="0"/>
+          <a:chOff x="0" y="0"/>
+          <a:chExt cx="0" cy="0"/>
+        </a:xfrm>
+      </p:grpSpPr>
+      <p:sp>
+        <p:nvSpPr>
+          <p:cNvPr id="2" name="TextBox 2"/>
+          <p:cNvSpPr txBox="1"/>
+          <p:nvPr/>
+        </p:nvSpPr>
+        <p:spPr>
+          <a:xfrm>
+            <a:off x="323849" y="182553"/>
+            <a:ext cx="1562101" cy="332848"/>
+          </a:xfrm>
+          <a:prstGeom prst="rect">
+            <a:avLst/>
+          </a:prstGeom>
+        </p:spPr>
+        <p:txBody>
+          <a:bodyPr wrap="square" lIns="0" tIns="0" rIns="0" bIns="0" rtlCol="0" anchor="t">
+            <a:spAutoFit/>
+          </a:bodyPr>
+          <a:lstStyle/>
+          <a:p>
+            <a:pPr algn="l">
+              <a:lnSpc>
+                <a:spcPts val="2869"/>
+              </a:lnSpc>
+            </a:pPr>
+            <a:r>
+              <a:rPr lang="en-US" sz="2049" b="1" dirty="0" err="1">
+                <a:solidFill>
+                  <a:srgbClr val="2B4D7B"/>
+                </a:solidFill>
+                <a:latin typeface="Tahoma" panose="020B0604030504040204" pitchFamily="34" charset="0"/>
+                <a:ea typeface="Tahoma" panose="020B0604030504040204" pitchFamily="34" charset="0"/>
+                <a:cs typeface="Tahoma" panose="020B0604030504040204" pitchFamily="34" charset="0"/>
+                <a:sym typeface="Canva Sans Bold"/>
+              </a:rPr>
+              <a:t>Nội</a:t>
+            </a:r>
+            <a:r>
+              <a:rPr lang="en-US" sz="2049" b="1" dirty="0">
+                <a:solidFill>
+                  <a:srgbClr val="2B4D7B"/>
+                </a:solidFill>
+                <a:latin typeface="Tahoma" panose="020B0604030504040204" pitchFamily="34" charset="0"/>
+                <a:ea typeface="Tahoma" panose="020B0604030504040204" pitchFamily="34" charset="0"/>
+                <a:cs typeface="Tahoma" panose="020B0604030504040204" pitchFamily="34" charset="0"/>
+                <a:sym typeface="Canva Sans Bold"/>
+              </a:rPr>
+              <a:t> dung</a:t>
+            </a:r>
+          </a:p>
+        </p:txBody>
+      </p:sp>
+      <p:sp>
+        <p:nvSpPr>
+          <p:cNvPr id="3" name="TextBox 3"/>
+          <p:cNvSpPr txBox="1"/>
+          <p:nvPr/>
+        </p:nvSpPr>
+        <p:spPr>
+          <a:xfrm>
+            <a:off x="349411" y="731635"/>
+            <a:ext cx="3227945" cy="1736437"/>
+          </a:xfrm>
+          <a:prstGeom prst="rect">
+            <a:avLst/>
+          </a:prstGeom>
+        </p:spPr>
+        <p:txBody>
+          <a:bodyPr wrap="square" lIns="0" tIns="0" rIns="0" bIns="0" rtlCol="0" anchor="t">
+            <a:spAutoFit/>
+          </a:bodyPr>
+          <a:lstStyle/>
+          <a:p>
+            <a:pPr marL="228600" indent="-228600" algn="l">
+              <a:lnSpc>
+                <a:spcPts val="2304"/>
+              </a:lnSpc>
+              <a:buAutoNum type="arabicPeriod"/>
+            </a:pPr>
+            <a:r>
+              <a:rPr lang="en-US" sz="1200" b="1" dirty="0" err="1">
+                <a:solidFill>
+                  <a:srgbClr val="2B4D7B"/>
+                </a:solidFill>
+                <a:latin typeface="Tahoma" panose="020B0604030504040204" pitchFamily="34" charset="0"/>
+                <a:ea typeface="Tahoma" panose="020B0604030504040204" pitchFamily="34" charset="0"/>
+                <a:cs typeface="Tahoma" panose="020B0604030504040204" pitchFamily="34" charset="0"/>
+                <a:sym typeface="Canva Sans Bold"/>
+              </a:rPr>
+              <a:t>Giới</a:t>
+            </a:r>
+            <a:r>
+              <a:rPr lang="en-US" sz="1200" b="1" dirty="0">
+                <a:solidFill>
+                  <a:srgbClr val="2B4D7B"/>
+                </a:solidFill>
+                <a:latin typeface="Tahoma" panose="020B0604030504040204" pitchFamily="34" charset="0"/>
+                <a:ea typeface="Tahoma" panose="020B0604030504040204" pitchFamily="34" charset="0"/>
+                <a:cs typeface="Tahoma" panose="020B0604030504040204" pitchFamily="34" charset="0"/>
+                <a:sym typeface="Canva Sans Bold"/>
+              </a:rPr>
+              <a:t> </a:t>
+            </a:r>
+            <a:r>
+              <a:rPr lang="en-US" sz="1200" b="1" dirty="0" err="1">
+                <a:solidFill>
+                  <a:srgbClr val="2B4D7B"/>
+                </a:solidFill>
+                <a:latin typeface="Tahoma" panose="020B0604030504040204" pitchFamily="34" charset="0"/>
+                <a:ea typeface="Tahoma" panose="020B0604030504040204" pitchFamily="34" charset="0"/>
+                <a:cs typeface="Tahoma" panose="020B0604030504040204" pitchFamily="34" charset="0"/>
+                <a:sym typeface="Canva Sans Bold"/>
+              </a:rPr>
+              <a:t>thiệu</a:t>
+            </a:r>
+            <a:endParaRPr lang="en-US" sz="1200" b="1" dirty="0">
+              <a:solidFill>
+                <a:srgbClr val="2B4D7B"/>
+              </a:solidFill>
+              <a:latin typeface="Tahoma" panose="020B0604030504040204" pitchFamily="34" charset="0"/>
+              <a:ea typeface="Tahoma" panose="020B0604030504040204" pitchFamily="34" charset="0"/>
+              <a:cs typeface="Tahoma" panose="020B0604030504040204" pitchFamily="34" charset="0"/>
+              <a:sym typeface="Canva Sans Bold"/>
+            </a:endParaRPr>
+          </a:p>
+          <a:p>
+            <a:pPr marL="228600" indent="-228600" algn="l">
+              <a:lnSpc>
+                <a:spcPts val="2304"/>
+              </a:lnSpc>
+              <a:buAutoNum type="arabicPeriod"/>
+            </a:pPr>
+            <a:r>
+              <a:rPr lang="en-US" sz="1200" b="1" dirty="0" err="1">
+                <a:solidFill>
+                  <a:srgbClr val="2B4D7B"/>
+                </a:solidFill>
+                <a:latin typeface="Tahoma" panose="020B0604030504040204" pitchFamily="34" charset="0"/>
+                <a:ea typeface="Tahoma" panose="020B0604030504040204" pitchFamily="34" charset="0"/>
+                <a:cs typeface="Tahoma" panose="020B0604030504040204" pitchFamily="34" charset="0"/>
+                <a:sym typeface="Canva Sans Bold"/>
+              </a:rPr>
+              <a:t>Bộ</a:t>
+            </a:r>
+            <a:r>
+              <a:rPr lang="en-US" sz="1200" b="1" dirty="0">
+                <a:solidFill>
+                  <a:srgbClr val="2B4D7B"/>
+                </a:solidFill>
+                <a:latin typeface="Tahoma" panose="020B0604030504040204" pitchFamily="34" charset="0"/>
+                <a:ea typeface="Tahoma" panose="020B0604030504040204" pitchFamily="34" charset="0"/>
+                <a:cs typeface="Tahoma" panose="020B0604030504040204" pitchFamily="34" charset="0"/>
+                <a:sym typeface="Canva Sans Bold"/>
+              </a:rPr>
+              <a:t> </a:t>
+            </a:r>
+            <a:r>
+              <a:rPr lang="en-US" sz="1200" b="1" dirty="0" err="1">
+                <a:solidFill>
+                  <a:srgbClr val="2B4D7B"/>
+                </a:solidFill>
+                <a:latin typeface="Tahoma" panose="020B0604030504040204" pitchFamily="34" charset="0"/>
+                <a:ea typeface="Tahoma" panose="020B0604030504040204" pitchFamily="34" charset="0"/>
+                <a:cs typeface="Tahoma" panose="020B0604030504040204" pitchFamily="34" charset="0"/>
+                <a:sym typeface="Canva Sans Bold"/>
+              </a:rPr>
+              <a:t>dữ</a:t>
+            </a:r>
+            <a:r>
+              <a:rPr lang="en-US" sz="1200" b="1" dirty="0">
+                <a:solidFill>
+                  <a:srgbClr val="2B4D7B"/>
+                </a:solidFill>
+                <a:latin typeface="Tahoma" panose="020B0604030504040204" pitchFamily="34" charset="0"/>
+                <a:ea typeface="Tahoma" panose="020B0604030504040204" pitchFamily="34" charset="0"/>
+                <a:cs typeface="Tahoma" panose="020B0604030504040204" pitchFamily="34" charset="0"/>
+                <a:sym typeface="Canva Sans Bold"/>
+              </a:rPr>
+              <a:t> </a:t>
+            </a:r>
+            <a:r>
+              <a:rPr lang="en-US" sz="1200" b="1" dirty="0" err="1">
+                <a:solidFill>
+                  <a:srgbClr val="2B4D7B"/>
+                </a:solidFill>
+                <a:latin typeface="Tahoma" panose="020B0604030504040204" pitchFamily="34" charset="0"/>
+                <a:ea typeface="Tahoma" panose="020B0604030504040204" pitchFamily="34" charset="0"/>
+                <a:cs typeface="Tahoma" panose="020B0604030504040204" pitchFamily="34" charset="0"/>
+                <a:sym typeface="Canva Sans Bold"/>
+              </a:rPr>
+              <a:t>liệu</a:t>
+            </a:r>
+            <a:endParaRPr lang="en-US" sz="1200" b="1" dirty="0">
+              <a:solidFill>
+                <a:srgbClr val="2B4D7B"/>
+              </a:solidFill>
+              <a:latin typeface="Tahoma" panose="020B0604030504040204" pitchFamily="34" charset="0"/>
+              <a:ea typeface="Tahoma" panose="020B0604030504040204" pitchFamily="34" charset="0"/>
+              <a:cs typeface="Tahoma" panose="020B0604030504040204" pitchFamily="34" charset="0"/>
+              <a:sym typeface="Canva Sans Bold"/>
+            </a:endParaRPr>
+          </a:p>
+          <a:p>
+            <a:pPr marL="228600" indent="-228600" algn="l">
+              <a:lnSpc>
+                <a:spcPts val="2304"/>
+              </a:lnSpc>
+              <a:buAutoNum type="arabicPeriod"/>
+            </a:pPr>
+            <a:r>
+              <a:rPr lang="en-US" sz="1200" b="1" dirty="0" err="1">
+                <a:solidFill>
+                  <a:srgbClr val="2B4D7B"/>
+                </a:solidFill>
+                <a:latin typeface="Tahoma" panose="020B0604030504040204" pitchFamily="34" charset="0"/>
+                <a:ea typeface="Tahoma" panose="020B0604030504040204" pitchFamily="34" charset="0"/>
+                <a:cs typeface="Tahoma" panose="020B0604030504040204" pitchFamily="34" charset="0"/>
+                <a:sym typeface="Canva Sans Bold"/>
+              </a:rPr>
+              <a:t>Chỉ</a:t>
+            </a:r>
+            <a:r>
+              <a:rPr lang="en-US" sz="1200" b="1" dirty="0">
+                <a:solidFill>
+                  <a:srgbClr val="2B4D7B"/>
+                </a:solidFill>
+                <a:latin typeface="Tahoma" panose="020B0604030504040204" pitchFamily="34" charset="0"/>
+                <a:ea typeface="Tahoma" panose="020B0604030504040204" pitchFamily="34" charset="0"/>
+                <a:cs typeface="Tahoma" panose="020B0604030504040204" pitchFamily="34" charset="0"/>
+                <a:sym typeface="Canva Sans Bold"/>
+              </a:rPr>
+              <a:t> </a:t>
+            </a:r>
+            <a:r>
+              <a:rPr lang="en-US" sz="1200" b="1" dirty="0" err="1">
+                <a:solidFill>
+                  <a:srgbClr val="2B4D7B"/>
+                </a:solidFill>
+                <a:latin typeface="Tahoma" panose="020B0604030504040204" pitchFamily="34" charset="0"/>
+                <a:ea typeface="Tahoma" panose="020B0604030504040204" pitchFamily="34" charset="0"/>
+                <a:cs typeface="Tahoma" panose="020B0604030504040204" pitchFamily="34" charset="0"/>
+                <a:sym typeface="Canva Sans Bold"/>
+              </a:rPr>
+              <a:t>số</a:t>
+            </a:r>
+            <a:r>
+              <a:rPr lang="en-US" sz="1200" b="1" dirty="0">
+                <a:solidFill>
+                  <a:srgbClr val="2B4D7B"/>
+                </a:solidFill>
+                <a:latin typeface="Tahoma" panose="020B0604030504040204" pitchFamily="34" charset="0"/>
+                <a:ea typeface="Tahoma" panose="020B0604030504040204" pitchFamily="34" charset="0"/>
+                <a:cs typeface="Tahoma" panose="020B0604030504040204" pitchFamily="34" charset="0"/>
+                <a:sym typeface="Canva Sans Bold"/>
+              </a:rPr>
+              <a:t> </a:t>
+            </a:r>
+            <a:r>
+              <a:rPr lang="en-US" sz="1200" b="1" dirty="0" err="1">
+                <a:solidFill>
+                  <a:srgbClr val="2B4D7B"/>
+                </a:solidFill>
+                <a:latin typeface="Tahoma" panose="020B0604030504040204" pitchFamily="34" charset="0"/>
+                <a:ea typeface="Tahoma" panose="020B0604030504040204" pitchFamily="34" charset="0"/>
+                <a:cs typeface="Tahoma" panose="020B0604030504040204" pitchFamily="34" charset="0"/>
+                <a:sym typeface="Canva Sans Bold"/>
+              </a:rPr>
+              <a:t>đánh</a:t>
+            </a:r>
+            <a:r>
+              <a:rPr lang="en-US" sz="1200" b="1" dirty="0">
+                <a:solidFill>
+                  <a:srgbClr val="2B4D7B"/>
+                </a:solidFill>
+                <a:latin typeface="Tahoma" panose="020B0604030504040204" pitchFamily="34" charset="0"/>
+                <a:ea typeface="Tahoma" panose="020B0604030504040204" pitchFamily="34" charset="0"/>
+                <a:cs typeface="Tahoma" panose="020B0604030504040204" pitchFamily="34" charset="0"/>
+                <a:sym typeface="Canva Sans Bold"/>
+              </a:rPr>
+              <a:t> </a:t>
+            </a:r>
+            <a:r>
+              <a:rPr lang="en-US" sz="1200" b="1" dirty="0" err="1">
+                <a:solidFill>
+                  <a:srgbClr val="2B4D7B"/>
+                </a:solidFill>
+                <a:latin typeface="Tahoma" panose="020B0604030504040204" pitchFamily="34" charset="0"/>
+                <a:ea typeface="Tahoma" panose="020B0604030504040204" pitchFamily="34" charset="0"/>
+                <a:cs typeface="Tahoma" panose="020B0604030504040204" pitchFamily="34" charset="0"/>
+                <a:sym typeface="Canva Sans Bold"/>
+              </a:rPr>
+              <a:t>giá</a:t>
+            </a:r>
+            <a:endParaRPr lang="en-US" sz="1200" b="1" dirty="0">
+              <a:solidFill>
+                <a:srgbClr val="2B4D7B"/>
+              </a:solidFill>
+              <a:latin typeface="Tahoma" panose="020B0604030504040204" pitchFamily="34" charset="0"/>
+              <a:ea typeface="Tahoma" panose="020B0604030504040204" pitchFamily="34" charset="0"/>
+              <a:cs typeface="Tahoma" panose="020B0604030504040204" pitchFamily="34" charset="0"/>
+              <a:sym typeface="Canva Sans Bold"/>
+            </a:endParaRPr>
+          </a:p>
+          <a:p>
+            <a:pPr marL="228600" indent="-228600" algn="l">
+              <a:lnSpc>
+                <a:spcPts val="2304"/>
+              </a:lnSpc>
+              <a:buAutoNum type="arabicPeriod"/>
+            </a:pPr>
+            <a:r>
+              <a:rPr lang="en-US" sz="1200" b="1" dirty="0">
+                <a:solidFill>
+                  <a:srgbClr val="2B4D7B"/>
+                </a:solidFill>
+                <a:latin typeface="Tahoma" panose="020B0604030504040204" pitchFamily="34" charset="0"/>
+                <a:ea typeface="Tahoma" panose="020B0604030504040204" pitchFamily="34" charset="0"/>
+                <a:cs typeface="Tahoma" panose="020B0604030504040204" pitchFamily="34" charset="0"/>
+                <a:sym typeface="Canva Sans Bold"/>
+              </a:rPr>
+              <a:t>Phương </a:t>
+            </a:r>
+            <a:r>
+              <a:rPr lang="en-US" sz="1200" b="1" dirty="0" err="1">
+                <a:solidFill>
+                  <a:srgbClr val="2B4D7B"/>
+                </a:solidFill>
+                <a:latin typeface="Tahoma" panose="020B0604030504040204" pitchFamily="34" charset="0"/>
+                <a:ea typeface="Tahoma" panose="020B0604030504040204" pitchFamily="34" charset="0"/>
+                <a:cs typeface="Tahoma" panose="020B0604030504040204" pitchFamily="34" charset="0"/>
+                <a:sym typeface="Canva Sans Bold"/>
+              </a:rPr>
+              <a:t>pháp</a:t>
+            </a:r>
+            <a:endParaRPr lang="en-US" sz="1200" b="1" dirty="0">
+              <a:solidFill>
+                <a:srgbClr val="2B4D7B"/>
+              </a:solidFill>
+              <a:latin typeface="Tahoma" panose="020B0604030504040204" pitchFamily="34" charset="0"/>
+              <a:ea typeface="Tahoma" panose="020B0604030504040204" pitchFamily="34" charset="0"/>
+              <a:cs typeface="Tahoma" panose="020B0604030504040204" pitchFamily="34" charset="0"/>
+              <a:sym typeface="Canva Sans Bold"/>
+            </a:endParaRPr>
+          </a:p>
+          <a:p>
+            <a:pPr marL="228600" indent="-228600" algn="l">
+              <a:lnSpc>
+                <a:spcPts val="2304"/>
+              </a:lnSpc>
+              <a:buAutoNum type="arabicPeriod"/>
+            </a:pPr>
+            <a:r>
+              <a:rPr lang="en-US" sz="1200" b="1" dirty="0" err="1">
+                <a:solidFill>
+                  <a:srgbClr val="2B4D7B"/>
+                </a:solidFill>
+                <a:latin typeface="Tahoma" panose="020B0604030504040204" pitchFamily="34" charset="0"/>
+                <a:ea typeface="Tahoma" panose="020B0604030504040204" pitchFamily="34" charset="0"/>
+                <a:cs typeface="Tahoma" panose="020B0604030504040204" pitchFamily="34" charset="0"/>
+                <a:sym typeface="Canva Sans Bold"/>
+              </a:rPr>
+              <a:t>Kết</a:t>
+            </a:r>
+            <a:r>
+              <a:rPr lang="en-US" sz="1200" b="1" dirty="0">
+                <a:solidFill>
+                  <a:srgbClr val="2B4D7B"/>
+                </a:solidFill>
+                <a:latin typeface="Tahoma" panose="020B0604030504040204" pitchFamily="34" charset="0"/>
+                <a:ea typeface="Tahoma" panose="020B0604030504040204" pitchFamily="34" charset="0"/>
+                <a:cs typeface="Tahoma" panose="020B0604030504040204" pitchFamily="34" charset="0"/>
+                <a:sym typeface="Canva Sans Bold"/>
+              </a:rPr>
+              <a:t> </a:t>
+            </a:r>
+            <a:r>
+              <a:rPr lang="en-US" sz="1200" b="1" dirty="0" err="1">
+                <a:solidFill>
+                  <a:srgbClr val="2B4D7B"/>
+                </a:solidFill>
+                <a:latin typeface="Tahoma" panose="020B0604030504040204" pitchFamily="34" charset="0"/>
+                <a:ea typeface="Tahoma" panose="020B0604030504040204" pitchFamily="34" charset="0"/>
+                <a:cs typeface="Tahoma" panose="020B0604030504040204" pitchFamily="34" charset="0"/>
+                <a:sym typeface="Canva Sans Bold"/>
+              </a:rPr>
+              <a:t>quả</a:t>
+            </a:r>
+            <a:r>
+              <a:rPr lang="en-US" sz="1200" b="1" dirty="0">
+                <a:solidFill>
+                  <a:srgbClr val="2B4D7B"/>
+                </a:solidFill>
+                <a:latin typeface="Tahoma" panose="020B0604030504040204" pitchFamily="34" charset="0"/>
+                <a:ea typeface="Tahoma" panose="020B0604030504040204" pitchFamily="34" charset="0"/>
+                <a:cs typeface="Tahoma" panose="020B0604030504040204" pitchFamily="34" charset="0"/>
+                <a:sym typeface="Canva Sans Bold"/>
+              </a:rPr>
+              <a:t> </a:t>
+            </a:r>
+            <a:r>
+              <a:rPr lang="en-US" sz="1200" b="1" dirty="0" err="1">
+                <a:solidFill>
+                  <a:srgbClr val="2B4D7B"/>
+                </a:solidFill>
+                <a:latin typeface="Tahoma" panose="020B0604030504040204" pitchFamily="34" charset="0"/>
+                <a:ea typeface="Tahoma" panose="020B0604030504040204" pitchFamily="34" charset="0"/>
+                <a:cs typeface="Tahoma" panose="020B0604030504040204" pitchFamily="34" charset="0"/>
+                <a:sym typeface="Canva Sans Bold"/>
+              </a:rPr>
+              <a:t>thực</a:t>
+            </a:r>
+            <a:r>
+              <a:rPr lang="en-US" sz="1200" b="1" dirty="0">
+                <a:solidFill>
+                  <a:srgbClr val="2B4D7B"/>
+                </a:solidFill>
+                <a:latin typeface="Tahoma" panose="020B0604030504040204" pitchFamily="34" charset="0"/>
+                <a:ea typeface="Tahoma" panose="020B0604030504040204" pitchFamily="34" charset="0"/>
+                <a:cs typeface="Tahoma" panose="020B0604030504040204" pitchFamily="34" charset="0"/>
+                <a:sym typeface="Canva Sans Bold"/>
+              </a:rPr>
+              <a:t> </a:t>
+            </a:r>
+            <a:r>
+              <a:rPr lang="en-US" sz="1200" b="1" dirty="0" err="1">
+                <a:solidFill>
+                  <a:srgbClr val="2B4D7B"/>
+                </a:solidFill>
+                <a:latin typeface="Tahoma" panose="020B0604030504040204" pitchFamily="34" charset="0"/>
+                <a:ea typeface="Tahoma" panose="020B0604030504040204" pitchFamily="34" charset="0"/>
+                <a:cs typeface="Tahoma" panose="020B0604030504040204" pitchFamily="34" charset="0"/>
+                <a:sym typeface="Canva Sans Bold"/>
+              </a:rPr>
+              <a:t>nghiệm</a:t>
+            </a:r>
+            <a:endParaRPr lang="en-US" sz="1200" b="1" dirty="0">
+              <a:solidFill>
+                <a:srgbClr val="2B4D7B"/>
+              </a:solidFill>
+              <a:latin typeface="Tahoma" panose="020B0604030504040204" pitchFamily="34" charset="0"/>
+              <a:ea typeface="Tahoma" panose="020B0604030504040204" pitchFamily="34" charset="0"/>
+              <a:cs typeface="Tahoma" panose="020B0604030504040204" pitchFamily="34" charset="0"/>
+              <a:sym typeface="Canva Sans Bold"/>
+            </a:endParaRPr>
+          </a:p>
+          <a:p>
+            <a:pPr marL="228600" indent="-228600" algn="l">
+              <a:lnSpc>
+                <a:spcPts val="2304"/>
+              </a:lnSpc>
+              <a:buAutoNum type="arabicPeriod"/>
+            </a:pPr>
+            <a:r>
+              <a:rPr lang="en-US" sz="1200" b="1" dirty="0" err="1">
+                <a:solidFill>
+                  <a:srgbClr val="2B4D7B"/>
+                </a:solidFill>
+                <a:latin typeface="Tahoma" panose="020B0604030504040204" pitchFamily="34" charset="0"/>
+                <a:ea typeface="Tahoma" panose="020B0604030504040204" pitchFamily="34" charset="0"/>
+                <a:cs typeface="Tahoma" panose="020B0604030504040204" pitchFamily="34" charset="0"/>
+                <a:sym typeface="Canva Sans Bold"/>
+              </a:rPr>
+              <a:t>Kết</a:t>
+            </a:r>
+            <a:r>
+              <a:rPr lang="en-US" sz="1200" b="1" dirty="0">
+                <a:solidFill>
+                  <a:srgbClr val="2B4D7B"/>
+                </a:solidFill>
+                <a:latin typeface="Tahoma" panose="020B0604030504040204" pitchFamily="34" charset="0"/>
+                <a:ea typeface="Tahoma" panose="020B0604030504040204" pitchFamily="34" charset="0"/>
+                <a:cs typeface="Tahoma" panose="020B0604030504040204" pitchFamily="34" charset="0"/>
+                <a:sym typeface="Canva Sans Bold"/>
+              </a:rPr>
+              <a:t> </a:t>
+            </a:r>
+            <a:r>
+              <a:rPr lang="en-US" sz="1200" b="1" dirty="0" err="1">
+                <a:solidFill>
+                  <a:srgbClr val="2B4D7B"/>
+                </a:solidFill>
+                <a:latin typeface="Tahoma" panose="020B0604030504040204" pitchFamily="34" charset="0"/>
+                <a:ea typeface="Tahoma" panose="020B0604030504040204" pitchFamily="34" charset="0"/>
+                <a:cs typeface="Tahoma" panose="020B0604030504040204" pitchFamily="34" charset="0"/>
+                <a:sym typeface="Canva Sans Bold"/>
+              </a:rPr>
+              <a:t>luận</a:t>
+            </a:r>
+            <a:endParaRPr lang="en-US" sz="1200" b="1" dirty="0">
+              <a:solidFill>
+                <a:srgbClr val="2B4D7B"/>
+              </a:solidFill>
+              <a:latin typeface="Tahoma" panose="020B0604030504040204" pitchFamily="34" charset="0"/>
+              <a:ea typeface="Tahoma" panose="020B0604030504040204" pitchFamily="34" charset="0"/>
+              <a:cs typeface="Tahoma" panose="020B0604030504040204" pitchFamily="34" charset="0"/>
+              <a:sym typeface="Canva Sans Bold"/>
+            </a:endParaRPr>
+          </a:p>
+        </p:txBody>
+      </p:sp>
+      <p:sp>
+        <p:nvSpPr>
+          <p:cNvPr id="6" name="TextBox 5">
+            <a:extLst>
+              <a:ext uri="{FF2B5EF4-FFF2-40B4-BE49-F238E27FC236}">
+                <a16:creationId xmlns:a16="http://schemas.microsoft.com/office/drawing/2014/main" id="{1A3B45B4-54EB-D63C-8B42-A98CADA42C8D}"/>
+              </a:ext>
+            </a:extLst>
+          </p:cNvPr>
+          <p:cNvSpPr txBox="1"/>
+          <p:nvPr/>
+        </p:nvSpPr>
+        <p:spPr>
+          <a:xfrm>
+            <a:off x="5391150" y="2914650"/>
+            <a:ext cx="219075" cy="215444"/>
+          </a:xfrm>
+          <a:prstGeom prst="rect">
+            <a:avLst/>
+          </a:prstGeom>
+          <a:noFill/>
+        </p:spPr>
+        <p:txBody>
+          <a:bodyPr wrap="square">
+            <a:spAutoFit/>
+          </a:bodyPr>
+          <a:lstStyle/>
+          <a:p>
+            <a:pPr algn="r"/>
+            <a:r>
+              <a:rPr lang="en-US" sz="800" dirty="0">
+                <a:solidFill>
+                  <a:srgbClr val="1C1C1A"/>
+                </a:solidFill>
+                <a:latin typeface="Tahoma" panose="020B0604030504040204" pitchFamily="34" charset="0"/>
+                <a:ea typeface="Tahoma" panose="020B0604030504040204" pitchFamily="34" charset="0"/>
+                <a:cs typeface="Tahoma" panose="020B0604030504040204" pitchFamily="34" charset="0"/>
+                <a:sym typeface="Canva Sans"/>
+              </a:rPr>
+              <a:t>1</a:t>
+            </a:r>
+            <a:endParaRPr lang="en-US" sz="800" dirty="0">
+              <a:latin typeface="Tahoma" panose="020B0604030504040204" pitchFamily="34" charset="0"/>
+              <a:ea typeface="Tahoma" panose="020B0604030504040204" pitchFamily="34" charset="0"/>
+              <a:cs typeface="Tahoma" panose="020B0604030504040204" pitchFamily="34" charset="0"/>
+            </a:endParaRPr>
+          </a:p>
+        </p:txBody>
+      </p:sp>
+    </p:spTree>
+  </p:cSld>
+  <p:clrMapOvr>
+    <a:masterClrMapping/>
+  </p:clrMapOvr>
+</p:sld>
+</file>
+
+<file path=ppt/slides/slide20.xml><?xml version="1.0" encoding="utf-8"?>
 <p:sld xmlns:a="http://schemas.openxmlformats.org/drawingml/2006/main" xmlns:r="http://schemas.openxmlformats.org/officeDocument/2006/relationships" xmlns:p="http://schemas.openxmlformats.org/presentationml/2006/main">
   <p:cSld>
     <p:spTree>
@@ -8638,589 +10904,6 @@
               </a:rPr>
               <a:t>!</a:t>
             </a:r>
-          </a:p>
-        </p:txBody>
-      </p:sp>
-    </p:spTree>
-  </p:cSld>
-  <p:clrMapOvr>
-    <a:masterClrMapping/>
-  </p:clrMapOvr>
-</p:sld>
-</file>
-
-<file path=ppt/slides/slide2.xml><?xml version="1.0" encoding="utf-8"?>
-<p:sld xmlns:a="http://schemas.openxmlformats.org/drawingml/2006/main" xmlns:r="http://schemas.openxmlformats.org/officeDocument/2006/relationships" xmlns:p="http://schemas.openxmlformats.org/presentationml/2006/main">
-  <p:cSld>
-    <p:bg>
-      <p:bgPr>
-        <a:solidFill>
-          <a:srgbClr val="F4F8FF"/>
-        </a:solidFill>
-        <a:effectLst/>
-      </p:bgPr>
-    </p:bg>
-    <p:spTree>
-      <p:nvGrpSpPr>
-        <p:cNvPr id="1" name=""/>
-        <p:cNvGrpSpPr/>
-        <p:nvPr/>
-      </p:nvGrpSpPr>
-      <p:grpSpPr>
-        <a:xfrm>
-          <a:off x="0" y="0"/>
-          <a:ext cx="0" cy="0"/>
-          <a:chOff x="0" y="0"/>
-          <a:chExt cx="0" cy="0"/>
-        </a:xfrm>
-      </p:grpSpPr>
-      <p:sp>
-        <p:nvSpPr>
-          <p:cNvPr id="2" name="TextBox 2"/>
-          <p:cNvSpPr txBox="1"/>
-          <p:nvPr/>
-        </p:nvSpPr>
-        <p:spPr>
-          <a:xfrm>
-            <a:off x="323849" y="182553"/>
-            <a:ext cx="1562101" cy="332848"/>
-          </a:xfrm>
-          <a:prstGeom prst="rect">
-            <a:avLst/>
-          </a:prstGeom>
-        </p:spPr>
-        <p:txBody>
-          <a:bodyPr wrap="square" lIns="0" tIns="0" rIns="0" bIns="0" rtlCol="0" anchor="t">
-            <a:spAutoFit/>
-          </a:bodyPr>
-          <a:lstStyle/>
-          <a:p>
-            <a:pPr algn="l">
-              <a:lnSpc>
-                <a:spcPts val="2869"/>
-              </a:lnSpc>
-            </a:pPr>
-            <a:r>
-              <a:rPr lang="en-US" sz="2049" b="1" dirty="0" err="1">
-                <a:solidFill>
-                  <a:srgbClr val="2B4D7B"/>
-                </a:solidFill>
-                <a:latin typeface="Tahoma" panose="020B0604030504040204" pitchFamily="34" charset="0"/>
-                <a:ea typeface="Tahoma" panose="020B0604030504040204" pitchFamily="34" charset="0"/>
-                <a:cs typeface="Tahoma" panose="020B0604030504040204" pitchFamily="34" charset="0"/>
-                <a:sym typeface="Canva Sans Bold"/>
-              </a:rPr>
-              <a:t>Nội</a:t>
-            </a:r>
-            <a:r>
-              <a:rPr lang="en-US" sz="2049" b="1" dirty="0">
-                <a:solidFill>
-                  <a:srgbClr val="2B4D7B"/>
-                </a:solidFill>
-                <a:latin typeface="Tahoma" panose="020B0604030504040204" pitchFamily="34" charset="0"/>
-                <a:ea typeface="Tahoma" panose="020B0604030504040204" pitchFamily="34" charset="0"/>
-                <a:cs typeface="Tahoma" panose="020B0604030504040204" pitchFamily="34" charset="0"/>
-                <a:sym typeface="Canva Sans Bold"/>
-              </a:rPr>
-              <a:t> dung</a:t>
-            </a:r>
-          </a:p>
-        </p:txBody>
-      </p:sp>
-      <p:sp>
-        <p:nvSpPr>
-          <p:cNvPr id="3" name="TextBox 3"/>
-          <p:cNvSpPr txBox="1"/>
-          <p:nvPr/>
-        </p:nvSpPr>
-        <p:spPr>
-          <a:xfrm>
-            <a:off x="349411" y="731635"/>
-            <a:ext cx="3227945" cy="1736437"/>
-          </a:xfrm>
-          <a:prstGeom prst="rect">
-            <a:avLst/>
-          </a:prstGeom>
-        </p:spPr>
-        <p:txBody>
-          <a:bodyPr wrap="square" lIns="0" tIns="0" rIns="0" bIns="0" rtlCol="0" anchor="t">
-            <a:spAutoFit/>
-          </a:bodyPr>
-          <a:lstStyle/>
-          <a:p>
-            <a:pPr marL="228600" indent="-228600" algn="l">
-              <a:lnSpc>
-                <a:spcPts val="2304"/>
-              </a:lnSpc>
-              <a:buAutoNum type="arabicPeriod"/>
-            </a:pPr>
-            <a:r>
-              <a:rPr lang="en-US" sz="1200" b="1" dirty="0" err="1">
-                <a:solidFill>
-                  <a:srgbClr val="2B4D7B"/>
-                </a:solidFill>
-                <a:latin typeface="Tahoma" panose="020B0604030504040204" pitchFamily="34" charset="0"/>
-                <a:ea typeface="Tahoma" panose="020B0604030504040204" pitchFamily="34" charset="0"/>
-                <a:cs typeface="Tahoma" panose="020B0604030504040204" pitchFamily="34" charset="0"/>
-                <a:sym typeface="Canva Sans Bold"/>
-              </a:rPr>
-              <a:t>Giới</a:t>
-            </a:r>
-            <a:r>
-              <a:rPr lang="en-US" sz="1200" b="1" dirty="0">
-                <a:solidFill>
-                  <a:srgbClr val="2B4D7B"/>
-                </a:solidFill>
-                <a:latin typeface="Tahoma" panose="020B0604030504040204" pitchFamily="34" charset="0"/>
-                <a:ea typeface="Tahoma" panose="020B0604030504040204" pitchFamily="34" charset="0"/>
-                <a:cs typeface="Tahoma" panose="020B0604030504040204" pitchFamily="34" charset="0"/>
-                <a:sym typeface="Canva Sans Bold"/>
-              </a:rPr>
-              <a:t> </a:t>
-            </a:r>
-            <a:r>
-              <a:rPr lang="en-US" sz="1200" b="1" dirty="0" err="1">
-                <a:solidFill>
-                  <a:srgbClr val="2B4D7B"/>
-                </a:solidFill>
-                <a:latin typeface="Tahoma" panose="020B0604030504040204" pitchFamily="34" charset="0"/>
-                <a:ea typeface="Tahoma" panose="020B0604030504040204" pitchFamily="34" charset="0"/>
-                <a:cs typeface="Tahoma" panose="020B0604030504040204" pitchFamily="34" charset="0"/>
-                <a:sym typeface="Canva Sans Bold"/>
-              </a:rPr>
-              <a:t>thiệu</a:t>
-            </a:r>
-            <a:endParaRPr lang="en-US" sz="1200" b="1" dirty="0">
-              <a:solidFill>
-                <a:srgbClr val="2B4D7B"/>
-              </a:solidFill>
-              <a:latin typeface="Tahoma" panose="020B0604030504040204" pitchFamily="34" charset="0"/>
-              <a:ea typeface="Tahoma" panose="020B0604030504040204" pitchFamily="34" charset="0"/>
-              <a:cs typeface="Tahoma" panose="020B0604030504040204" pitchFamily="34" charset="0"/>
-              <a:sym typeface="Canva Sans Bold"/>
-            </a:endParaRPr>
-          </a:p>
-          <a:p>
-            <a:pPr marL="228600" indent="-228600" algn="l">
-              <a:lnSpc>
-                <a:spcPts val="2304"/>
-              </a:lnSpc>
-              <a:buAutoNum type="arabicPeriod"/>
-            </a:pPr>
-            <a:r>
-              <a:rPr lang="en-US" sz="1200" b="1" dirty="0" err="1">
-                <a:solidFill>
-                  <a:srgbClr val="2B4D7B"/>
-                </a:solidFill>
-                <a:latin typeface="Tahoma" panose="020B0604030504040204" pitchFamily="34" charset="0"/>
-                <a:ea typeface="Tahoma" panose="020B0604030504040204" pitchFamily="34" charset="0"/>
-                <a:cs typeface="Tahoma" panose="020B0604030504040204" pitchFamily="34" charset="0"/>
-                <a:sym typeface="Canva Sans Bold"/>
-              </a:rPr>
-              <a:t>Bộ</a:t>
-            </a:r>
-            <a:r>
-              <a:rPr lang="en-US" sz="1200" b="1" dirty="0">
-                <a:solidFill>
-                  <a:srgbClr val="2B4D7B"/>
-                </a:solidFill>
-                <a:latin typeface="Tahoma" panose="020B0604030504040204" pitchFamily="34" charset="0"/>
-                <a:ea typeface="Tahoma" panose="020B0604030504040204" pitchFamily="34" charset="0"/>
-                <a:cs typeface="Tahoma" panose="020B0604030504040204" pitchFamily="34" charset="0"/>
-                <a:sym typeface="Canva Sans Bold"/>
-              </a:rPr>
-              <a:t> </a:t>
-            </a:r>
-            <a:r>
-              <a:rPr lang="en-US" sz="1200" b="1" dirty="0" err="1">
-                <a:solidFill>
-                  <a:srgbClr val="2B4D7B"/>
-                </a:solidFill>
-                <a:latin typeface="Tahoma" panose="020B0604030504040204" pitchFamily="34" charset="0"/>
-                <a:ea typeface="Tahoma" panose="020B0604030504040204" pitchFamily="34" charset="0"/>
-                <a:cs typeface="Tahoma" panose="020B0604030504040204" pitchFamily="34" charset="0"/>
-                <a:sym typeface="Canva Sans Bold"/>
-              </a:rPr>
-              <a:t>dữ</a:t>
-            </a:r>
-            <a:r>
-              <a:rPr lang="en-US" sz="1200" b="1" dirty="0">
-                <a:solidFill>
-                  <a:srgbClr val="2B4D7B"/>
-                </a:solidFill>
-                <a:latin typeface="Tahoma" panose="020B0604030504040204" pitchFamily="34" charset="0"/>
-                <a:ea typeface="Tahoma" panose="020B0604030504040204" pitchFamily="34" charset="0"/>
-                <a:cs typeface="Tahoma" panose="020B0604030504040204" pitchFamily="34" charset="0"/>
-                <a:sym typeface="Canva Sans Bold"/>
-              </a:rPr>
-              <a:t> </a:t>
-            </a:r>
-            <a:r>
-              <a:rPr lang="en-US" sz="1200" b="1" dirty="0" err="1">
-                <a:solidFill>
-                  <a:srgbClr val="2B4D7B"/>
-                </a:solidFill>
-                <a:latin typeface="Tahoma" panose="020B0604030504040204" pitchFamily="34" charset="0"/>
-                <a:ea typeface="Tahoma" panose="020B0604030504040204" pitchFamily="34" charset="0"/>
-                <a:cs typeface="Tahoma" panose="020B0604030504040204" pitchFamily="34" charset="0"/>
-                <a:sym typeface="Canva Sans Bold"/>
-              </a:rPr>
-              <a:t>liệu</a:t>
-            </a:r>
-            <a:endParaRPr lang="en-US" sz="1200" b="1" dirty="0">
-              <a:solidFill>
-                <a:srgbClr val="2B4D7B"/>
-              </a:solidFill>
-              <a:latin typeface="Tahoma" panose="020B0604030504040204" pitchFamily="34" charset="0"/>
-              <a:ea typeface="Tahoma" panose="020B0604030504040204" pitchFamily="34" charset="0"/>
-              <a:cs typeface="Tahoma" panose="020B0604030504040204" pitchFamily="34" charset="0"/>
-              <a:sym typeface="Canva Sans Bold"/>
-            </a:endParaRPr>
-          </a:p>
-          <a:p>
-            <a:pPr marL="228600" indent="-228600" algn="l">
-              <a:lnSpc>
-                <a:spcPts val="2304"/>
-              </a:lnSpc>
-              <a:buAutoNum type="arabicPeriod"/>
-            </a:pPr>
-            <a:r>
-              <a:rPr lang="en-US" sz="1200" b="1" dirty="0" err="1">
-                <a:solidFill>
-                  <a:srgbClr val="2B4D7B"/>
-                </a:solidFill>
-                <a:latin typeface="Tahoma" panose="020B0604030504040204" pitchFamily="34" charset="0"/>
-                <a:ea typeface="Tahoma" panose="020B0604030504040204" pitchFamily="34" charset="0"/>
-                <a:cs typeface="Tahoma" panose="020B0604030504040204" pitchFamily="34" charset="0"/>
-                <a:sym typeface="Canva Sans Bold"/>
-              </a:rPr>
-              <a:t>Chỉ</a:t>
-            </a:r>
-            <a:r>
-              <a:rPr lang="en-US" sz="1200" b="1" dirty="0">
-                <a:solidFill>
-                  <a:srgbClr val="2B4D7B"/>
-                </a:solidFill>
-                <a:latin typeface="Tahoma" panose="020B0604030504040204" pitchFamily="34" charset="0"/>
-                <a:ea typeface="Tahoma" panose="020B0604030504040204" pitchFamily="34" charset="0"/>
-                <a:cs typeface="Tahoma" panose="020B0604030504040204" pitchFamily="34" charset="0"/>
-                <a:sym typeface="Canva Sans Bold"/>
-              </a:rPr>
-              <a:t> </a:t>
-            </a:r>
-            <a:r>
-              <a:rPr lang="en-US" sz="1200" b="1" dirty="0" err="1">
-                <a:solidFill>
-                  <a:srgbClr val="2B4D7B"/>
-                </a:solidFill>
-                <a:latin typeface="Tahoma" panose="020B0604030504040204" pitchFamily="34" charset="0"/>
-                <a:ea typeface="Tahoma" panose="020B0604030504040204" pitchFamily="34" charset="0"/>
-                <a:cs typeface="Tahoma" panose="020B0604030504040204" pitchFamily="34" charset="0"/>
-                <a:sym typeface="Canva Sans Bold"/>
-              </a:rPr>
-              <a:t>số</a:t>
-            </a:r>
-            <a:r>
-              <a:rPr lang="en-US" sz="1200" b="1" dirty="0">
-                <a:solidFill>
-                  <a:srgbClr val="2B4D7B"/>
-                </a:solidFill>
-                <a:latin typeface="Tahoma" panose="020B0604030504040204" pitchFamily="34" charset="0"/>
-                <a:ea typeface="Tahoma" panose="020B0604030504040204" pitchFamily="34" charset="0"/>
-                <a:cs typeface="Tahoma" panose="020B0604030504040204" pitchFamily="34" charset="0"/>
-                <a:sym typeface="Canva Sans Bold"/>
-              </a:rPr>
-              <a:t> </a:t>
-            </a:r>
-            <a:r>
-              <a:rPr lang="en-US" sz="1200" b="1" dirty="0" err="1">
-                <a:solidFill>
-                  <a:srgbClr val="2B4D7B"/>
-                </a:solidFill>
-                <a:latin typeface="Tahoma" panose="020B0604030504040204" pitchFamily="34" charset="0"/>
-                <a:ea typeface="Tahoma" panose="020B0604030504040204" pitchFamily="34" charset="0"/>
-                <a:cs typeface="Tahoma" panose="020B0604030504040204" pitchFamily="34" charset="0"/>
-                <a:sym typeface="Canva Sans Bold"/>
-              </a:rPr>
-              <a:t>đánh</a:t>
-            </a:r>
-            <a:r>
-              <a:rPr lang="en-US" sz="1200" b="1" dirty="0">
-                <a:solidFill>
-                  <a:srgbClr val="2B4D7B"/>
-                </a:solidFill>
-                <a:latin typeface="Tahoma" panose="020B0604030504040204" pitchFamily="34" charset="0"/>
-                <a:ea typeface="Tahoma" panose="020B0604030504040204" pitchFamily="34" charset="0"/>
-                <a:cs typeface="Tahoma" panose="020B0604030504040204" pitchFamily="34" charset="0"/>
-                <a:sym typeface="Canva Sans Bold"/>
-              </a:rPr>
-              <a:t> </a:t>
-            </a:r>
-            <a:r>
-              <a:rPr lang="en-US" sz="1200" b="1" dirty="0" err="1">
-                <a:solidFill>
-                  <a:srgbClr val="2B4D7B"/>
-                </a:solidFill>
-                <a:latin typeface="Tahoma" panose="020B0604030504040204" pitchFamily="34" charset="0"/>
-                <a:ea typeface="Tahoma" panose="020B0604030504040204" pitchFamily="34" charset="0"/>
-                <a:cs typeface="Tahoma" panose="020B0604030504040204" pitchFamily="34" charset="0"/>
-                <a:sym typeface="Canva Sans Bold"/>
-              </a:rPr>
-              <a:t>giá</a:t>
-            </a:r>
-            <a:endParaRPr lang="en-US" sz="1200" b="1" dirty="0">
-              <a:solidFill>
-                <a:srgbClr val="2B4D7B"/>
-              </a:solidFill>
-              <a:latin typeface="Tahoma" panose="020B0604030504040204" pitchFamily="34" charset="0"/>
-              <a:ea typeface="Tahoma" panose="020B0604030504040204" pitchFamily="34" charset="0"/>
-              <a:cs typeface="Tahoma" panose="020B0604030504040204" pitchFamily="34" charset="0"/>
-              <a:sym typeface="Canva Sans Bold"/>
-            </a:endParaRPr>
-          </a:p>
-          <a:p>
-            <a:pPr marL="228600" indent="-228600" algn="l">
-              <a:lnSpc>
-                <a:spcPts val="2304"/>
-              </a:lnSpc>
-              <a:buAutoNum type="arabicPeriod"/>
-            </a:pPr>
-            <a:r>
-              <a:rPr lang="en-US" sz="1200" b="1" dirty="0">
-                <a:solidFill>
-                  <a:srgbClr val="2B4D7B"/>
-                </a:solidFill>
-                <a:latin typeface="Tahoma" panose="020B0604030504040204" pitchFamily="34" charset="0"/>
-                <a:ea typeface="Tahoma" panose="020B0604030504040204" pitchFamily="34" charset="0"/>
-                <a:cs typeface="Tahoma" panose="020B0604030504040204" pitchFamily="34" charset="0"/>
-                <a:sym typeface="Canva Sans Bold"/>
-              </a:rPr>
-              <a:t>Phương </a:t>
-            </a:r>
-            <a:r>
-              <a:rPr lang="en-US" sz="1200" b="1" dirty="0" err="1">
-                <a:solidFill>
-                  <a:srgbClr val="2B4D7B"/>
-                </a:solidFill>
-                <a:latin typeface="Tahoma" panose="020B0604030504040204" pitchFamily="34" charset="0"/>
-                <a:ea typeface="Tahoma" panose="020B0604030504040204" pitchFamily="34" charset="0"/>
-                <a:cs typeface="Tahoma" panose="020B0604030504040204" pitchFamily="34" charset="0"/>
-                <a:sym typeface="Canva Sans Bold"/>
-              </a:rPr>
-              <a:t>pháp</a:t>
-            </a:r>
-            <a:endParaRPr lang="en-US" sz="1200" b="1" dirty="0">
-              <a:solidFill>
-                <a:srgbClr val="2B4D7B"/>
-              </a:solidFill>
-              <a:latin typeface="Tahoma" panose="020B0604030504040204" pitchFamily="34" charset="0"/>
-              <a:ea typeface="Tahoma" panose="020B0604030504040204" pitchFamily="34" charset="0"/>
-              <a:cs typeface="Tahoma" panose="020B0604030504040204" pitchFamily="34" charset="0"/>
-              <a:sym typeface="Canva Sans Bold"/>
-            </a:endParaRPr>
-          </a:p>
-          <a:p>
-            <a:pPr marL="228600" indent="-228600" algn="l">
-              <a:lnSpc>
-                <a:spcPts val="2304"/>
-              </a:lnSpc>
-              <a:buAutoNum type="arabicPeriod"/>
-            </a:pPr>
-            <a:r>
-              <a:rPr lang="en-US" sz="1200" b="1" dirty="0" err="1">
-                <a:solidFill>
-                  <a:srgbClr val="2B4D7B"/>
-                </a:solidFill>
-                <a:latin typeface="Tahoma" panose="020B0604030504040204" pitchFamily="34" charset="0"/>
-                <a:ea typeface="Tahoma" panose="020B0604030504040204" pitchFamily="34" charset="0"/>
-                <a:cs typeface="Tahoma" panose="020B0604030504040204" pitchFamily="34" charset="0"/>
-                <a:sym typeface="Canva Sans Bold"/>
-              </a:rPr>
-              <a:t>Kết</a:t>
-            </a:r>
-            <a:r>
-              <a:rPr lang="en-US" sz="1200" b="1" dirty="0">
-                <a:solidFill>
-                  <a:srgbClr val="2B4D7B"/>
-                </a:solidFill>
-                <a:latin typeface="Tahoma" panose="020B0604030504040204" pitchFamily="34" charset="0"/>
-                <a:ea typeface="Tahoma" panose="020B0604030504040204" pitchFamily="34" charset="0"/>
-                <a:cs typeface="Tahoma" panose="020B0604030504040204" pitchFamily="34" charset="0"/>
-                <a:sym typeface="Canva Sans Bold"/>
-              </a:rPr>
-              <a:t> </a:t>
-            </a:r>
-            <a:r>
-              <a:rPr lang="en-US" sz="1200" b="1" dirty="0" err="1">
-                <a:solidFill>
-                  <a:srgbClr val="2B4D7B"/>
-                </a:solidFill>
-                <a:latin typeface="Tahoma" panose="020B0604030504040204" pitchFamily="34" charset="0"/>
-                <a:ea typeface="Tahoma" panose="020B0604030504040204" pitchFamily="34" charset="0"/>
-                <a:cs typeface="Tahoma" panose="020B0604030504040204" pitchFamily="34" charset="0"/>
-                <a:sym typeface="Canva Sans Bold"/>
-              </a:rPr>
-              <a:t>quả</a:t>
-            </a:r>
-            <a:r>
-              <a:rPr lang="en-US" sz="1200" b="1" dirty="0">
-                <a:solidFill>
-                  <a:srgbClr val="2B4D7B"/>
-                </a:solidFill>
-                <a:latin typeface="Tahoma" panose="020B0604030504040204" pitchFamily="34" charset="0"/>
-                <a:ea typeface="Tahoma" panose="020B0604030504040204" pitchFamily="34" charset="0"/>
-                <a:cs typeface="Tahoma" panose="020B0604030504040204" pitchFamily="34" charset="0"/>
-                <a:sym typeface="Canva Sans Bold"/>
-              </a:rPr>
-              <a:t> </a:t>
-            </a:r>
-            <a:r>
-              <a:rPr lang="en-US" sz="1200" b="1" dirty="0" err="1">
-                <a:solidFill>
-                  <a:srgbClr val="2B4D7B"/>
-                </a:solidFill>
-                <a:latin typeface="Tahoma" panose="020B0604030504040204" pitchFamily="34" charset="0"/>
-                <a:ea typeface="Tahoma" panose="020B0604030504040204" pitchFamily="34" charset="0"/>
-                <a:cs typeface="Tahoma" panose="020B0604030504040204" pitchFamily="34" charset="0"/>
-                <a:sym typeface="Canva Sans Bold"/>
-              </a:rPr>
-              <a:t>thực</a:t>
-            </a:r>
-            <a:r>
-              <a:rPr lang="en-US" sz="1200" b="1" dirty="0">
-                <a:solidFill>
-                  <a:srgbClr val="2B4D7B"/>
-                </a:solidFill>
-                <a:latin typeface="Tahoma" panose="020B0604030504040204" pitchFamily="34" charset="0"/>
-                <a:ea typeface="Tahoma" panose="020B0604030504040204" pitchFamily="34" charset="0"/>
-                <a:cs typeface="Tahoma" panose="020B0604030504040204" pitchFamily="34" charset="0"/>
-                <a:sym typeface="Canva Sans Bold"/>
-              </a:rPr>
-              <a:t> </a:t>
-            </a:r>
-            <a:r>
-              <a:rPr lang="en-US" sz="1200" b="1" dirty="0" err="1">
-                <a:solidFill>
-                  <a:srgbClr val="2B4D7B"/>
-                </a:solidFill>
-                <a:latin typeface="Tahoma" panose="020B0604030504040204" pitchFamily="34" charset="0"/>
-                <a:ea typeface="Tahoma" panose="020B0604030504040204" pitchFamily="34" charset="0"/>
-                <a:cs typeface="Tahoma" panose="020B0604030504040204" pitchFamily="34" charset="0"/>
-                <a:sym typeface="Canva Sans Bold"/>
-              </a:rPr>
-              <a:t>nghiệm</a:t>
-            </a:r>
-            <a:endParaRPr lang="en-US" sz="1200" b="1" dirty="0">
-              <a:solidFill>
-                <a:srgbClr val="2B4D7B"/>
-              </a:solidFill>
-              <a:latin typeface="Tahoma" panose="020B0604030504040204" pitchFamily="34" charset="0"/>
-              <a:ea typeface="Tahoma" panose="020B0604030504040204" pitchFamily="34" charset="0"/>
-              <a:cs typeface="Tahoma" panose="020B0604030504040204" pitchFamily="34" charset="0"/>
-              <a:sym typeface="Canva Sans Bold"/>
-            </a:endParaRPr>
-          </a:p>
-          <a:p>
-            <a:pPr marL="228600" indent="-228600" algn="l">
-              <a:lnSpc>
-                <a:spcPts val="2304"/>
-              </a:lnSpc>
-              <a:buAutoNum type="arabicPeriod"/>
-            </a:pPr>
-            <a:r>
-              <a:rPr lang="en-US" sz="1200" b="1" dirty="0" err="1">
-                <a:solidFill>
-                  <a:srgbClr val="2B4D7B"/>
-                </a:solidFill>
-                <a:latin typeface="Tahoma" panose="020B0604030504040204" pitchFamily="34" charset="0"/>
-                <a:ea typeface="Tahoma" panose="020B0604030504040204" pitchFamily="34" charset="0"/>
-                <a:cs typeface="Tahoma" panose="020B0604030504040204" pitchFamily="34" charset="0"/>
-                <a:sym typeface="Canva Sans Bold"/>
-              </a:rPr>
-              <a:t>Kết</a:t>
-            </a:r>
-            <a:r>
-              <a:rPr lang="en-US" sz="1200" b="1" dirty="0">
-                <a:solidFill>
-                  <a:srgbClr val="2B4D7B"/>
-                </a:solidFill>
-                <a:latin typeface="Tahoma" panose="020B0604030504040204" pitchFamily="34" charset="0"/>
-                <a:ea typeface="Tahoma" panose="020B0604030504040204" pitchFamily="34" charset="0"/>
-                <a:cs typeface="Tahoma" panose="020B0604030504040204" pitchFamily="34" charset="0"/>
-                <a:sym typeface="Canva Sans Bold"/>
-              </a:rPr>
-              <a:t> </a:t>
-            </a:r>
-            <a:r>
-              <a:rPr lang="en-US" sz="1200" b="1" dirty="0" err="1">
-                <a:solidFill>
-                  <a:srgbClr val="2B4D7B"/>
-                </a:solidFill>
-                <a:latin typeface="Tahoma" panose="020B0604030504040204" pitchFamily="34" charset="0"/>
-                <a:ea typeface="Tahoma" panose="020B0604030504040204" pitchFamily="34" charset="0"/>
-                <a:cs typeface="Tahoma" panose="020B0604030504040204" pitchFamily="34" charset="0"/>
-                <a:sym typeface="Canva Sans Bold"/>
-              </a:rPr>
-              <a:t>luận</a:t>
-            </a:r>
-            <a:endParaRPr lang="en-US" sz="1200" b="1" dirty="0">
-              <a:solidFill>
-                <a:srgbClr val="2B4D7B"/>
-              </a:solidFill>
-              <a:latin typeface="Tahoma" panose="020B0604030504040204" pitchFamily="34" charset="0"/>
-              <a:ea typeface="Tahoma" panose="020B0604030504040204" pitchFamily="34" charset="0"/>
-              <a:cs typeface="Tahoma" panose="020B0604030504040204" pitchFamily="34" charset="0"/>
-              <a:sym typeface="Canva Sans Bold"/>
-            </a:endParaRPr>
-          </a:p>
-        </p:txBody>
-      </p:sp>
-      <p:sp>
-        <p:nvSpPr>
-          <p:cNvPr id="6" name="TextBox 5">
-            <a:extLst>
-              <a:ext uri="{FF2B5EF4-FFF2-40B4-BE49-F238E27FC236}">
-                <a16:creationId xmlns:a16="http://schemas.microsoft.com/office/drawing/2014/main" id="{1A3B45B4-54EB-D63C-8B42-A98CADA42C8D}"/>
-              </a:ext>
-            </a:extLst>
-          </p:cNvPr>
-          <p:cNvSpPr txBox="1"/>
-          <p:nvPr/>
-        </p:nvSpPr>
-        <p:spPr>
-          <a:xfrm>
-            <a:off x="5391150" y="2914650"/>
-            <a:ext cx="219075" cy="215444"/>
-          </a:xfrm>
-          <a:prstGeom prst="rect">
-            <a:avLst/>
-          </a:prstGeom>
-          <a:noFill/>
-        </p:spPr>
-        <p:txBody>
-          <a:bodyPr wrap="square">
-            <a:spAutoFit/>
-          </a:bodyPr>
-          <a:lstStyle/>
-          <a:p>
-            <a:pPr algn="r"/>
-            <a:r>
-              <a:rPr lang="en-US" sz="800" dirty="0">
-                <a:solidFill>
-                  <a:srgbClr val="1C1C1A"/>
-                </a:solidFill>
-                <a:latin typeface="Tahoma" panose="020B0604030504040204" pitchFamily="34" charset="0"/>
-                <a:ea typeface="Tahoma" panose="020B0604030504040204" pitchFamily="34" charset="0"/>
-                <a:cs typeface="Tahoma" panose="020B0604030504040204" pitchFamily="34" charset="0"/>
-                <a:sym typeface="Canva Sans"/>
-              </a:rPr>
-              <a:t>1</a:t>
-            </a:r>
-            <a:endParaRPr lang="en-US" sz="800" dirty="0">
-              <a:latin typeface="Tahoma" panose="020B0604030504040204" pitchFamily="34" charset="0"/>
-              <a:ea typeface="Tahoma" panose="020B0604030504040204" pitchFamily="34" charset="0"/>
-              <a:cs typeface="Tahoma" panose="020B0604030504040204" pitchFamily="34" charset="0"/>
-            </a:endParaRPr>
           </a:p>
         </p:txBody>
       </p:sp>

</xml_diff>